<commit_message>
entrega de ultima version presentacion
</commit_message>
<xml_diff>
--- a/docs/Presentacion_Final_Steam_Classifier.pptx
+++ b/docs/Presentacion_Final_Steam_Classifier.pptx
@@ -302,7 +302,7 @@
       </p15:sldGuideLst>
     </p:ext>
     <p:ext uri="GoogleSlidesCustomDataVersion2">
-      <go:slidesCustomData xmlns:go="http://customooxmlschemas.google.com/" r:id="rId52" roundtripDataSignature="AMtx7mgEwJ5mOdiEYAgqaOBmIyu2dIf81A=="/>
+      <go:slidesCustomData xmlns:go="http://customooxmlschemas.google.com/" r:id="rId52" roundtripDataSignature="AMtx7mgjIaXcSdamNvsQsjF7DB3EOgmCtQ=="/>
     </p:ext>
   </p:extLst>
 </p:presentation>
@@ -838,7 +838,7 @@
   <p:cSld>
     <p:spTree>
       <p:nvGrpSpPr>
-        <p:cNvPr id="137" name="Shape 137"/>
+        <p:cNvPr id="139" name="Shape 139"/>
         <p:cNvGrpSpPr/>
         <p:nvPr/>
       </p:nvGrpSpPr>
@@ -852,7 +852,7 @@
       </p:grpSpPr>
       <p:sp>
         <p:nvSpPr>
-          <p:cNvPr id="138" name="Google Shape;138;p10:notes"/>
+          <p:cNvPr id="140" name="Google Shape;140;p10:notes"/>
           <p:cNvSpPr txBox="1"/>
           <p:nvPr>
             <p:ph idx="1" type="body"/>
@@ -891,7 +891,7 @@
       </p:sp>
       <p:sp>
         <p:nvSpPr>
-          <p:cNvPr id="139" name="Google Shape;139;p10:notes"/>
+          <p:cNvPr id="141" name="Google Shape;141;p10:notes"/>
           <p:cNvSpPr/>
           <p:nvPr>
             <p:ph idx="2" type="sldImg"/>
@@ -937,7 +937,7 @@
   <p:cSld>
     <p:spTree>
       <p:nvGrpSpPr>
-        <p:cNvPr id="143" name="Shape 143"/>
+        <p:cNvPr id="145" name="Shape 145"/>
         <p:cNvGrpSpPr/>
         <p:nvPr/>
       </p:nvGrpSpPr>
@@ -951,7 +951,7 @@
       </p:grpSpPr>
       <p:sp>
         <p:nvSpPr>
-          <p:cNvPr id="144" name="Google Shape;144;p11:notes"/>
+          <p:cNvPr id="146" name="Google Shape;146;p11:notes"/>
           <p:cNvSpPr txBox="1"/>
           <p:nvPr>
             <p:ph idx="1" type="body"/>
@@ -990,7 +990,7 @@
       </p:sp>
       <p:sp>
         <p:nvSpPr>
-          <p:cNvPr id="145" name="Google Shape;145;p11:notes"/>
+          <p:cNvPr id="147" name="Google Shape;147;p11:notes"/>
           <p:cNvSpPr/>
           <p:nvPr>
             <p:ph idx="2" type="sldImg"/>
@@ -1036,7 +1036,7 @@
   <p:cSld>
     <p:spTree>
       <p:nvGrpSpPr>
-        <p:cNvPr id="150" name="Shape 150"/>
+        <p:cNvPr id="152" name="Shape 152"/>
         <p:cNvGrpSpPr/>
         <p:nvPr/>
       </p:nvGrpSpPr>
@@ -1050,7 +1050,7 @@
       </p:grpSpPr>
       <p:sp>
         <p:nvSpPr>
-          <p:cNvPr id="151" name="Google Shape;151;g394273392e2_0_19:notes"/>
+          <p:cNvPr id="153" name="Google Shape;153;g394273392e2_0_19:notes"/>
           <p:cNvSpPr/>
           <p:nvPr>
             <p:ph idx="2" type="sldImg"/>
@@ -1085,7 +1085,7 @@
       </p:sp>
       <p:sp>
         <p:nvSpPr>
-          <p:cNvPr id="152" name="Google Shape;152;g394273392e2_0_19:notes"/>
+          <p:cNvPr id="154" name="Google Shape;154;g394273392e2_0_19:notes"/>
           <p:cNvSpPr txBox="1"/>
           <p:nvPr>
             <p:ph idx="1" type="body"/>
@@ -1135,7 +1135,7 @@
   <p:cSld>
     <p:spTree>
       <p:nvGrpSpPr>
-        <p:cNvPr id="156" name="Shape 156"/>
+        <p:cNvPr id="158" name="Shape 158"/>
         <p:cNvGrpSpPr/>
         <p:nvPr/>
       </p:nvGrpSpPr>
@@ -1149,7 +1149,7 @@
       </p:grpSpPr>
       <p:sp>
         <p:nvSpPr>
-          <p:cNvPr id="157" name="Google Shape;157;p12:notes"/>
+          <p:cNvPr id="159" name="Google Shape;159;p12:notes"/>
           <p:cNvSpPr txBox="1"/>
           <p:nvPr>
             <p:ph idx="1" type="body"/>
@@ -1188,7 +1188,7 @@
       </p:sp>
       <p:sp>
         <p:nvSpPr>
-          <p:cNvPr id="158" name="Google Shape;158;p12:notes"/>
+          <p:cNvPr id="160" name="Google Shape;160;p12:notes"/>
           <p:cNvSpPr/>
           <p:nvPr>
             <p:ph idx="2" type="sldImg"/>
@@ -1234,7 +1234,7 @@
   <p:cSld>
     <p:spTree>
       <p:nvGrpSpPr>
-        <p:cNvPr id="162" name="Shape 162"/>
+        <p:cNvPr id="164" name="Shape 164"/>
         <p:cNvGrpSpPr/>
         <p:nvPr/>
       </p:nvGrpSpPr>
@@ -1248,7 +1248,7 @@
       </p:grpSpPr>
       <p:sp>
         <p:nvSpPr>
-          <p:cNvPr id="163" name="Google Shape;163;p13:notes"/>
+          <p:cNvPr id="165" name="Google Shape;165;p13:notes"/>
           <p:cNvSpPr txBox="1"/>
           <p:nvPr>
             <p:ph idx="1" type="body"/>
@@ -1287,7 +1287,7 @@
       </p:sp>
       <p:sp>
         <p:nvSpPr>
-          <p:cNvPr id="164" name="Google Shape;164;p13:notes"/>
+          <p:cNvPr id="166" name="Google Shape;166;p13:notes"/>
           <p:cNvSpPr/>
           <p:nvPr>
             <p:ph idx="2" type="sldImg"/>
@@ -1333,7 +1333,7 @@
   <p:cSld>
     <p:spTree>
       <p:nvGrpSpPr>
-        <p:cNvPr id="168" name="Shape 168"/>
+        <p:cNvPr id="170" name="Shape 170"/>
         <p:cNvGrpSpPr/>
         <p:nvPr/>
       </p:nvGrpSpPr>
@@ -1347,7 +1347,7 @@
       </p:grpSpPr>
       <p:sp>
         <p:nvSpPr>
-          <p:cNvPr id="169" name="Google Shape;169;p14:notes"/>
+          <p:cNvPr id="171" name="Google Shape;171;p14:notes"/>
           <p:cNvSpPr txBox="1"/>
           <p:nvPr>
             <p:ph idx="1" type="body"/>
@@ -1386,7 +1386,7 @@
       </p:sp>
       <p:sp>
         <p:nvSpPr>
-          <p:cNvPr id="170" name="Google Shape;170;p14:notes"/>
+          <p:cNvPr id="172" name="Google Shape;172;p14:notes"/>
           <p:cNvSpPr/>
           <p:nvPr>
             <p:ph idx="2" type="sldImg"/>
@@ -1432,7 +1432,7 @@
   <p:cSld>
     <p:spTree>
       <p:nvGrpSpPr>
-        <p:cNvPr id="174" name="Shape 174"/>
+        <p:cNvPr id="176" name="Shape 176"/>
         <p:cNvGrpSpPr/>
         <p:nvPr/>
       </p:nvGrpSpPr>
@@ -1446,7 +1446,7 @@
       </p:grpSpPr>
       <p:sp>
         <p:nvSpPr>
-          <p:cNvPr id="175" name="Google Shape;175;p15:notes"/>
+          <p:cNvPr id="177" name="Google Shape;177;p15:notes"/>
           <p:cNvSpPr txBox="1"/>
           <p:nvPr>
             <p:ph idx="1" type="body"/>
@@ -1485,7 +1485,7 @@
       </p:sp>
       <p:sp>
         <p:nvSpPr>
-          <p:cNvPr id="176" name="Google Shape;176;p15:notes"/>
+          <p:cNvPr id="178" name="Google Shape;178;p15:notes"/>
           <p:cNvSpPr/>
           <p:nvPr>
             <p:ph idx="2" type="sldImg"/>
@@ -1531,7 +1531,7 @@
   <p:cSld>
     <p:spTree>
       <p:nvGrpSpPr>
-        <p:cNvPr id="180" name="Shape 180"/>
+        <p:cNvPr id="182" name="Shape 182"/>
         <p:cNvGrpSpPr/>
         <p:nvPr/>
       </p:nvGrpSpPr>
@@ -1545,7 +1545,7 @@
       </p:grpSpPr>
       <p:sp>
         <p:nvSpPr>
-          <p:cNvPr id="181" name="Google Shape;181;p16:notes"/>
+          <p:cNvPr id="183" name="Google Shape;183;p16:notes"/>
           <p:cNvSpPr txBox="1"/>
           <p:nvPr>
             <p:ph idx="1" type="body"/>
@@ -1584,7 +1584,7 @@
       </p:sp>
       <p:sp>
         <p:nvSpPr>
-          <p:cNvPr id="182" name="Google Shape;182;p16:notes"/>
+          <p:cNvPr id="184" name="Google Shape;184;p16:notes"/>
           <p:cNvSpPr/>
           <p:nvPr>
             <p:ph idx="2" type="sldImg"/>
@@ -1630,7 +1630,7 @@
   <p:cSld>
     <p:spTree>
       <p:nvGrpSpPr>
-        <p:cNvPr id="186" name="Shape 186"/>
+        <p:cNvPr id="188" name="Shape 188"/>
         <p:cNvGrpSpPr/>
         <p:nvPr/>
       </p:nvGrpSpPr>
@@ -1644,7 +1644,7 @@
       </p:grpSpPr>
       <p:sp>
         <p:nvSpPr>
-          <p:cNvPr id="187" name="Google Shape;187;g3c8a0caada3_0_22:notes"/>
+          <p:cNvPr id="189" name="Google Shape;189;g3c8a0caada3_0_22:notes"/>
           <p:cNvSpPr/>
           <p:nvPr>
             <p:ph idx="2" type="sldImg"/>
@@ -1679,7 +1679,7 @@
       </p:sp>
       <p:sp>
         <p:nvSpPr>
-          <p:cNvPr id="188" name="Google Shape;188;g3c8a0caada3_0_22:notes"/>
+          <p:cNvPr id="190" name="Google Shape;190;g3c8a0caada3_0_22:notes"/>
           <p:cNvSpPr txBox="1"/>
           <p:nvPr>
             <p:ph idx="1" type="body"/>
@@ -1729,7 +1729,7 @@
   <p:cSld>
     <p:spTree>
       <p:nvGrpSpPr>
-        <p:cNvPr id="192" name="Shape 192"/>
+        <p:cNvPr id="194" name="Shape 194"/>
         <p:cNvGrpSpPr/>
         <p:nvPr/>
       </p:nvGrpSpPr>
@@ -1743,7 +1743,7 @@
       </p:grpSpPr>
       <p:sp>
         <p:nvSpPr>
-          <p:cNvPr id="193" name="Google Shape;193;p17:notes"/>
+          <p:cNvPr id="195" name="Google Shape;195;p17:notes"/>
           <p:cNvSpPr txBox="1"/>
           <p:nvPr>
             <p:ph idx="1" type="body"/>
@@ -1782,7 +1782,7 @@
       </p:sp>
       <p:sp>
         <p:nvSpPr>
-          <p:cNvPr id="194" name="Google Shape;194;p17:notes"/>
+          <p:cNvPr id="196" name="Google Shape;196;p17:notes"/>
           <p:cNvSpPr/>
           <p:nvPr>
             <p:ph idx="2" type="sldImg"/>
@@ -1927,7 +1927,7 @@
   <p:cSld>
     <p:spTree>
       <p:nvGrpSpPr>
-        <p:cNvPr id="198" name="Shape 198"/>
+        <p:cNvPr id="200" name="Shape 200"/>
         <p:cNvGrpSpPr/>
         <p:nvPr/>
       </p:nvGrpSpPr>
@@ -1941,7 +1941,7 @@
       </p:grpSpPr>
       <p:sp>
         <p:nvSpPr>
-          <p:cNvPr id="199" name="Google Shape;199;p18:notes"/>
+          <p:cNvPr id="201" name="Google Shape;201;p18:notes"/>
           <p:cNvSpPr txBox="1"/>
           <p:nvPr>
             <p:ph idx="1" type="body"/>
@@ -1980,7 +1980,7 @@
       </p:sp>
       <p:sp>
         <p:nvSpPr>
-          <p:cNvPr id="200" name="Google Shape;200;p18:notes"/>
+          <p:cNvPr id="202" name="Google Shape;202;p18:notes"/>
           <p:cNvSpPr/>
           <p:nvPr>
             <p:ph idx="2" type="sldImg"/>
@@ -2026,7 +2026,7 @@
   <p:cSld>
     <p:spTree>
       <p:nvGrpSpPr>
-        <p:cNvPr id="204" name="Shape 204"/>
+        <p:cNvPr id="206" name="Shape 206"/>
         <p:cNvGrpSpPr/>
         <p:nvPr/>
       </p:nvGrpSpPr>
@@ -2040,7 +2040,7 @@
       </p:grpSpPr>
       <p:sp>
         <p:nvSpPr>
-          <p:cNvPr id="205" name="Google Shape;205;p19:notes"/>
+          <p:cNvPr id="207" name="Google Shape;207;p19:notes"/>
           <p:cNvSpPr txBox="1"/>
           <p:nvPr>
             <p:ph idx="1" type="body"/>
@@ -2079,7 +2079,7 @@
       </p:sp>
       <p:sp>
         <p:nvSpPr>
-          <p:cNvPr id="206" name="Google Shape;206;p19:notes"/>
+          <p:cNvPr id="208" name="Google Shape;208;p19:notes"/>
           <p:cNvSpPr/>
           <p:nvPr>
             <p:ph idx="2" type="sldImg"/>
@@ -2125,7 +2125,7 @@
   <p:cSld>
     <p:spTree>
       <p:nvGrpSpPr>
-        <p:cNvPr id="210" name="Shape 210"/>
+        <p:cNvPr id="212" name="Shape 212"/>
         <p:cNvGrpSpPr/>
         <p:nvPr/>
       </p:nvGrpSpPr>
@@ -2139,7 +2139,7 @@
       </p:grpSpPr>
       <p:sp>
         <p:nvSpPr>
-          <p:cNvPr id="211" name="Google Shape;211;p20:notes"/>
+          <p:cNvPr id="213" name="Google Shape;213;p20:notes"/>
           <p:cNvSpPr txBox="1"/>
           <p:nvPr>
             <p:ph idx="1" type="body"/>
@@ -2178,7 +2178,7 @@
       </p:sp>
       <p:sp>
         <p:nvSpPr>
-          <p:cNvPr id="212" name="Google Shape;212;p20:notes"/>
+          <p:cNvPr id="214" name="Google Shape;214;p20:notes"/>
           <p:cNvSpPr/>
           <p:nvPr>
             <p:ph idx="2" type="sldImg"/>
@@ -2224,7 +2224,7 @@
   <p:cSld>
     <p:spTree>
       <p:nvGrpSpPr>
-        <p:cNvPr id="216" name="Shape 216"/>
+        <p:cNvPr id="218" name="Shape 218"/>
         <p:cNvGrpSpPr/>
         <p:nvPr/>
       </p:nvGrpSpPr>
@@ -2238,7 +2238,7 @@
       </p:grpSpPr>
       <p:sp>
         <p:nvSpPr>
-          <p:cNvPr id="217" name="Google Shape;217;p21:notes"/>
+          <p:cNvPr id="219" name="Google Shape;219;p21:notes"/>
           <p:cNvSpPr txBox="1"/>
           <p:nvPr>
             <p:ph idx="1" type="body"/>
@@ -2277,7 +2277,7 @@
       </p:sp>
       <p:sp>
         <p:nvSpPr>
-          <p:cNvPr id="218" name="Google Shape;218;p21:notes"/>
+          <p:cNvPr id="220" name="Google Shape;220;p21:notes"/>
           <p:cNvSpPr/>
           <p:nvPr>
             <p:ph idx="2" type="sldImg"/>
@@ -2323,7 +2323,7 @@
   <p:cSld>
     <p:spTree>
       <p:nvGrpSpPr>
-        <p:cNvPr id="222" name="Shape 222"/>
+        <p:cNvPr id="224" name="Shape 224"/>
         <p:cNvGrpSpPr/>
         <p:nvPr/>
       </p:nvGrpSpPr>
@@ -2337,7 +2337,7 @@
       </p:grpSpPr>
       <p:sp>
         <p:nvSpPr>
-          <p:cNvPr id="223" name="Google Shape;223;p22:notes"/>
+          <p:cNvPr id="225" name="Google Shape;225;p22:notes"/>
           <p:cNvSpPr txBox="1"/>
           <p:nvPr>
             <p:ph idx="1" type="body"/>
@@ -2376,7 +2376,7 @@
       </p:sp>
       <p:sp>
         <p:nvSpPr>
-          <p:cNvPr id="224" name="Google Shape;224;p22:notes"/>
+          <p:cNvPr id="226" name="Google Shape;226;p22:notes"/>
           <p:cNvSpPr/>
           <p:nvPr>
             <p:ph idx="2" type="sldImg"/>
@@ -2422,7 +2422,7 @@
   <p:cSld>
     <p:spTree>
       <p:nvGrpSpPr>
-        <p:cNvPr id="228" name="Shape 228"/>
+        <p:cNvPr id="230" name="Shape 230"/>
         <p:cNvGrpSpPr/>
         <p:nvPr/>
       </p:nvGrpSpPr>
@@ -2436,7 +2436,7 @@
       </p:grpSpPr>
       <p:sp>
         <p:nvSpPr>
-          <p:cNvPr id="229" name="Google Shape;229;p23:notes"/>
+          <p:cNvPr id="231" name="Google Shape;231;p23:notes"/>
           <p:cNvSpPr txBox="1"/>
           <p:nvPr>
             <p:ph idx="1" type="body"/>
@@ -2475,7 +2475,7 @@
       </p:sp>
       <p:sp>
         <p:nvSpPr>
-          <p:cNvPr id="230" name="Google Shape;230;p23:notes"/>
+          <p:cNvPr id="232" name="Google Shape;232;p23:notes"/>
           <p:cNvSpPr/>
           <p:nvPr>
             <p:ph idx="2" type="sldImg"/>
@@ -2521,7 +2521,7 @@
   <p:cSld>
     <p:spTree>
       <p:nvGrpSpPr>
-        <p:cNvPr id="234" name="Shape 234"/>
+        <p:cNvPr id="236" name="Shape 236"/>
         <p:cNvGrpSpPr/>
         <p:nvPr/>
       </p:nvGrpSpPr>
@@ -2535,7 +2535,7 @@
       </p:grpSpPr>
       <p:sp>
         <p:nvSpPr>
-          <p:cNvPr id="235" name="Google Shape;235;p24:notes"/>
+          <p:cNvPr id="237" name="Google Shape;237;p24:notes"/>
           <p:cNvSpPr txBox="1"/>
           <p:nvPr>
             <p:ph idx="1" type="body"/>
@@ -2574,7 +2574,7 @@
       </p:sp>
       <p:sp>
         <p:nvSpPr>
-          <p:cNvPr id="236" name="Google Shape;236;p24:notes"/>
+          <p:cNvPr id="238" name="Google Shape;238;p24:notes"/>
           <p:cNvSpPr/>
           <p:nvPr>
             <p:ph idx="2" type="sldImg"/>
@@ -2620,7 +2620,7 @@
   <p:cSld>
     <p:spTree>
       <p:nvGrpSpPr>
-        <p:cNvPr id="240" name="Shape 240"/>
+        <p:cNvPr id="242" name="Shape 242"/>
         <p:cNvGrpSpPr/>
         <p:nvPr/>
       </p:nvGrpSpPr>
@@ -2634,7 +2634,7 @@
       </p:grpSpPr>
       <p:sp>
         <p:nvSpPr>
-          <p:cNvPr id="241" name="Google Shape;241;p25:notes"/>
+          <p:cNvPr id="243" name="Google Shape;243;p25:notes"/>
           <p:cNvSpPr txBox="1"/>
           <p:nvPr>
             <p:ph idx="1" type="body"/>
@@ -2673,7 +2673,7 @@
       </p:sp>
       <p:sp>
         <p:nvSpPr>
-          <p:cNvPr id="242" name="Google Shape;242;p25:notes"/>
+          <p:cNvPr id="244" name="Google Shape;244;p25:notes"/>
           <p:cNvSpPr/>
           <p:nvPr>
             <p:ph idx="2" type="sldImg"/>
@@ -2719,7 +2719,7 @@
   <p:cSld>
     <p:spTree>
       <p:nvGrpSpPr>
-        <p:cNvPr id="246" name="Shape 246"/>
+        <p:cNvPr id="248" name="Shape 248"/>
         <p:cNvGrpSpPr/>
         <p:nvPr/>
       </p:nvGrpSpPr>
@@ -2733,7 +2733,7 @@
       </p:grpSpPr>
       <p:sp>
         <p:nvSpPr>
-          <p:cNvPr id="247" name="Google Shape;247;p26:notes"/>
+          <p:cNvPr id="249" name="Google Shape;249;p26:notes"/>
           <p:cNvSpPr txBox="1"/>
           <p:nvPr>
             <p:ph idx="1" type="body"/>
@@ -2772,7 +2772,7 @@
       </p:sp>
       <p:sp>
         <p:nvSpPr>
-          <p:cNvPr id="248" name="Google Shape;248;p26:notes"/>
+          <p:cNvPr id="250" name="Google Shape;250;p26:notes"/>
           <p:cNvSpPr/>
           <p:nvPr>
             <p:ph idx="2" type="sldImg"/>
@@ -2818,7 +2818,7 @@
   <p:cSld>
     <p:spTree>
       <p:nvGrpSpPr>
-        <p:cNvPr id="252" name="Shape 252"/>
+        <p:cNvPr id="254" name="Shape 254"/>
         <p:cNvGrpSpPr/>
         <p:nvPr/>
       </p:nvGrpSpPr>
@@ -2832,7 +2832,7 @@
       </p:grpSpPr>
       <p:sp>
         <p:nvSpPr>
-          <p:cNvPr id="253" name="Google Shape;253;p27:notes"/>
+          <p:cNvPr id="255" name="Google Shape;255;p27:notes"/>
           <p:cNvSpPr txBox="1"/>
           <p:nvPr>
             <p:ph idx="1" type="body"/>
@@ -2871,7 +2871,7 @@
       </p:sp>
       <p:sp>
         <p:nvSpPr>
-          <p:cNvPr id="254" name="Google Shape;254;p27:notes"/>
+          <p:cNvPr id="256" name="Google Shape;256;p27:notes"/>
           <p:cNvSpPr/>
           <p:nvPr>
             <p:ph idx="2" type="sldImg"/>
@@ -3016,7 +3016,7 @@
   <p:cSld>
     <p:spTree>
       <p:nvGrpSpPr>
-        <p:cNvPr id="258" name="Shape 258"/>
+        <p:cNvPr id="260" name="Shape 260"/>
         <p:cNvGrpSpPr/>
         <p:nvPr/>
       </p:nvGrpSpPr>
@@ -3030,7 +3030,7 @@
       </p:grpSpPr>
       <p:sp>
         <p:nvSpPr>
-          <p:cNvPr id="259" name="Google Shape;259;p28:notes"/>
+          <p:cNvPr id="261" name="Google Shape;261;p28:notes"/>
           <p:cNvSpPr txBox="1"/>
           <p:nvPr>
             <p:ph idx="1" type="body"/>
@@ -3069,7 +3069,7 @@
       </p:sp>
       <p:sp>
         <p:nvSpPr>
-          <p:cNvPr id="260" name="Google Shape;260;p28:notes"/>
+          <p:cNvPr id="262" name="Google Shape;262;p28:notes"/>
           <p:cNvSpPr/>
           <p:nvPr>
             <p:ph idx="2" type="sldImg"/>
@@ -3115,7 +3115,7 @@
   <p:cSld>
     <p:spTree>
       <p:nvGrpSpPr>
-        <p:cNvPr id="264" name="Shape 264"/>
+        <p:cNvPr id="266" name="Shape 266"/>
         <p:cNvGrpSpPr/>
         <p:nvPr/>
       </p:nvGrpSpPr>
@@ -3129,7 +3129,7 @@
       </p:grpSpPr>
       <p:sp>
         <p:nvSpPr>
-          <p:cNvPr id="265" name="Google Shape;265;p29:notes"/>
+          <p:cNvPr id="267" name="Google Shape;267;p29:notes"/>
           <p:cNvSpPr txBox="1"/>
           <p:nvPr>
             <p:ph idx="1" type="body"/>
@@ -3168,7 +3168,7 @@
       </p:sp>
       <p:sp>
         <p:nvSpPr>
-          <p:cNvPr id="266" name="Google Shape;266;p29:notes"/>
+          <p:cNvPr id="268" name="Google Shape;268;p29:notes"/>
           <p:cNvSpPr/>
           <p:nvPr>
             <p:ph idx="2" type="sldImg"/>
@@ -3214,7 +3214,7 @@
   <p:cSld>
     <p:spTree>
       <p:nvGrpSpPr>
-        <p:cNvPr id="272" name="Shape 272"/>
+        <p:cNvPr id="274" name="Shape 274"/>
         <p:cNvGrpSpPr/>
         <p:nvPr/>
       </p:nvGrpSpPr>
@@ -3228,7 +3228,7 @@
       </p:grpSpPr>
       <p:sp>
         <p:nvSpPr>
-          <p:cNvPr id="273" name="Google Shape;273;p30:notes"/>
+          <p:cNvPr id="275" name="Google Shape;275;p30:notes"/>
           <p:cNvSpPr txBox="1"/>
           <p:nvPr>
             <p:ph idx="1" type="body"/>
@@ -3267,7 +3267,7 @@
       </p:sp>
       <p:sp>
         <p:nvSpPr>
-          <p:cNvPr id="274" name="Google Shape;274;p30:notes"/>
+          <p:cNvPr id="276" name="Google Shape;276;p30:notes"/>
           <p:cNvSpPr/>
           <p:nvPr>
             <p:ph idx="2" type="sldImg"/>
@@ -3313,7 +3313,7 @@
   <p:cSld>
     <p:spTree>
       <p:nvGrpSpPr>
-        <p:cNvPr id="278" name="Shape 278"/>
+        <p:cNvPr id="280" name="Shape 280"/>
         <p:cNvGrpSpPr/>
         <p:nvPr/>
       </p:nvGrpSpPr>
@@ -3327,7 +3327,7 @@
       </p:grpSpPr>
       <p:sp>
         <p:nvSpPr>
-          <p:cNvPr id="279" name="Google Shape;279;p31:notes"/>
+          <p:cNvPr id="281" name="Google Shape;281;p31:notes"/>
           <p:cNvSpPr txBox="1"/>
           <p:nvPr>
             <p:ph idx="1" type="body"/>
@@ -3366,7 +3366,7 @@
       </p:sp>
       <p:sp>
         <p:nvSpPr>
-          <p:cNvPr id="280" name="Google Shape;280;p31:notes"/>
+          <p:cNvPr id="282" name="Google Shape;282;p31:notes"/>
           <p:cNvSpPr/>
           <p:nvPr>
             <p:ph idx="2" type="sldImg"/>
@@ -3412,7 +3412,7 @@
   <p:cSld>
     <p:spTree>
       <p:nvGrpSpPr>
-        <p:cNvPr id="284" name="Shape 284"/>
+        <p:cNvPr id="286" name="Shape 286"/>
         <p:cNvGrpSpPr/>
         <p:nvPr/>
       </p:nvGrpSpPr>
@@ -3426,7 +3426,7 @@
       </p:grpSpPr>
       <p:sp>
         <p:nvSpPr>
-          <p:cNvPr id="285" name="Google Shape;285;p32:notes"/>
+          <p:cNvPr id="287" name="Google Shape;287;p32:notes"/>
           <p:cNvSpPr txBox="1"/>
           <p:nvPr>
             <p:ph idx="1" type="body"/>
@@ -3465,7 +3465,7 @@
       </p:sp>
       <p:sp>
         <p:nvSpPr>
-          <p:cNvPr id="286" name="Google Shape;286;p32:notes"/>
+          <p:cNvPr id="288" name="Google Shape;288;p32:notes"/>
           <p:cNvSpPr/>
           <p:nvPr>
             <p:ph idx="2" type="sldImg"/>
@@ -3511,7 +3511,7 @@
   <p:cSld>
     <p:spTree>
       <p:nvGrpSpPr>
-        <p:cNvPr id="290" name="Shape 290"/>
+        <p:cNvPr id="292" name="Shape 292"/>
         <p:cNvGrpSpPr/>
         <p:nvPr/>
       </p:nvGrpSpPr>
@@ -3525,7 +3525,7 @@
       </p:grpSpPr>
       <p:sp>
         <p:nvSpPr>
-          <p:cNvPr id="291" name="Google Shape;291;g3c9478fcecd_0_0:notes"/>
+          <p:cNvPr id="293" name="Google Shape;293;g3c9478fcecd_0_0:notes"/>
           <p:cNvSpPr/>
           <p:nvPr>
             <p:ph idx="2" type="sldImg"/>
@@ -3560,7 +3560,7 @@
       </p:sp>
       <p:sp>
         <p:nvSpPr>
-          <p:cNvPr id="292" name="Google Shape;292;g3c9478fcecd_0_0:notes"/>
+          <p:cNvPr id="294" name="Google Shape;294;g3c9478fcecd_0_0:notes"/>
           <p:cNvSpPr txBox="1"/>
           <p:nvPr>
             <p:ph idx="1" type="body"/>
@@ -3610,7 +3610,7 @@
   <p:cSld>
     <p:spTree>
       <p:nvGrpSpPr>
-        <p:cNvPr id="296" name="Shape 296"/>
+        <p:cNvPr id="298" name="Shape 298"/>
         <p:cNvGrpSpPr/>
         <p:nvPr/>
       </p:nvGrpSpPr>
@@ -3624,7 +3624,7 @@
       </p:grpSpPr>
       <p:sp>
         <p:nvSpPr>
-          <p:cNvPr id="297" name="Google Shape;297;p33:notes"/>
+          <p:cNvPr id="299" name="Google Shape;299;p33:notes"/>
           <p:cNvSpPr txBox="1"/>
           <p:nvPr>
             <p:ph idx="1" type="body"/>
@@ -3663,7 +3663,7 @@
       </p:sp>
       <p:sp>
         <p:nvSpPr>
-          <p:cNvPr id="298" name="Google Shape;298;p33:notes"/>
+          <p:cNvPr id="300" name="Google Shape;300;p33:notes"/>
           <p:cNvSpPr/>
           <p:nvPr>
             <p:ph idx="2" type="sldImg"/>
@@ -3709,7 +3709,7 @@
   <p:cSld>
     <p:spTree>
       <p:nvGrpSpPr>
-        <p:cNvPr id="302" name="Shape 302"/>
+        <p:cNvPr id="304" name="Shape 304"/>
         <p:cNvGrpSpPr/>
         <p:nvPr/>
       </p:nvGrpSpPr>
@@ -3723,7 +3723,7 @@
       </p:grpSpPr>
       <p:sp>
         <p:nvSpPr>
-          <p:cNvPr id="303" name="Google Shape;303;p34:notes"/>
+          <p:cNvPr id="305" name="Google Shape;305;p34:notes"/>
           <p:cNvSpPr txBox="1"/>
           <p:nvPr>
             <p:ph idx="1" type="body"/>
@@ -3762,7 +3762,7 @@
       </p:sp>
       <p:sp>
         <p:nvSpPr>
-          <p:cNvPr id="304" name="Google Shape;304;p34:notes"/>
+          <p:cNvPr id="306" name="Google Shape;306;p34:notes"/>
           <p:cNvSpPr/>
           <p:nvPr>
             <p:ph idx="2" type="sldImg"/>
@@ -3808,7 +3808,7 @@
   <p:cSld>
     <p:spTree>
       <p:nvGrpSpPr>
-        <p:cNvPr id="308" name="Shape 308"/>
+        <p:cNvPr id="310" name="Shape 310"/>
         <p:cNvGrpSpPr/>
         <p:nvPr/>
       </p:nvGrpSpPr>
@@ -3822,7 +3822,7 @@
       </p:grpSpPr>
       <p:sp>
         <p:nvSpPr>
-          <p:cNvPr id="309" name="Google Shape;309;p35:notes"/>
+          <p:cNvPr id="311" name="Google Shape;311;p35:notes"/>
           <p:cNvSpPr txBox="1"/>
           <p:nvPr>
             <p:ph idx="1" type="body"/>
@@ -3861,7 +3861,7 @@
       </p:sp>
       <p:sp>
         <p:nvSpPr>
-          <p:cNvPr id="310" name="Google Shape;310;p35:notes"/>
+          <p:cNvPr id="312" name="Google Shape;312;p35:notes"/>
           <p:cNvSpPr/>
           <p:nvPr>
             <p:ph idx="2" type="sldImg"/>
@@ -3907,7 +3907,7 @@
   <p:cSld>
     <p:spTree>
       <p:nvGrpSpPr>
-        <p:cNvPr id="314" name="Shape 314"/>
+        <p:cNvPr id="316" name="Shape 316"/>
         <p:cNvGrpSpPr/>
         <p:nvPr/>
       </p:nvGrpSpPr>
@@ -3921,7 +3921,7 @@
       </p:grpSpPr>
       <p:sp>
         <p:nvSpPr>
-          <p:cNvPr id="315" name="Google Shape;315;p36:notes"/>
+          <p:cNvPr id="317" name="Google Shape;317;p36:notes"/>
           <p:cNvSpPr txBox="1"/>
           <p:nvPr>
             <p:ph idx="1" type="body"/>
@@ -3960,7 +3960,7 @@
       </p:sp>
       <p:sp>
         <p:nvSpPr>
-          <p:cNvPr id="316" name="Google Shape;316;p36:notes"/>
+          <p:cNvPr id="318" name="Google Shape;318;p36:notes"/>
           <p:cNvSpPr/>
           <p:nvPr>
             <p:ph idx="2" type="sldImg"/>
@@ -4105,7 +4105,7 @@
   <p:cSld>
     <p:spTree>
       <p:nvGrpSpPr>
-        <p:cNvPr id="320" name="Shape 320"/>
+        <p:cNvPr id="322" name="Shape 322"/>
         <p:cNvGrpSpPr/>
         <p:nvPr/>
       </p:nvGrpSpPr>
@@ -4119,7 +4119,7 @@
       </p:grpSpPr>
       <p:sp>
         <p:nvSpPr>
-          <p:cNvPr id="321" name="Google Shape;321;p37:notes"/>
+          <p:cNvPr id="323" name="Google Shape;323;p37:notes"/>
           <p:cNvSpPr txBox="1"/>
           <p:nvPr>
             <p:ph idx="1" type="body"/>
@@ -4158,7 +4158,7 @@
       </p:sp>
       <p:sp>
         <p:nvSpPr>
-          <p:cNvPr id="322" name="Google Shape;322;p37:notes"/>
+          <p:cNvPr id="324" name="Google Shape;324;p37:notes"/>
           <p:cNvSpPr/>
           <p:nvPr>
             <p:ph idx="2" type="sldImg"/>
@@ -4204,7 +4204,7 @@
   <p:cSld>
     <p:spTree>
       <p:nvGrpSpPr>
-        <p:cNvPr id="326" name="Shape 326"/>
+        <p:cNvPr id="328" name="Shape 328"/>
         <p:cNvGrpSpPr/>
         <p:nvPr/>
       </p:nvGrpSpPr>
@@ -4218,7 +4218,7 @@
       </p:grpSpPr>
       <p:sp>
         <p:nvSpPr>
-          <p:cNvPr id="327" name="Google Shape;327;g39421e1b5d2_0_0:notes"/>
+          <p:cNvPr id="329" name="Google Shape;329;g39421e1b5d2_0_0:notes"/>
           <p:cNvSpPr txBox="1"/>
           <p:nvPr>
             <p:ph idx="1" type="body"/>
@@ -4257,7 +4257,7 @@
       </p:sp>
       <p:sp>
         <p:nvSpPr>
-          <p:cNvPr id="328" name="Google Shape;328;g39421e1b5d2_0_0:notes"/>
+          <p:cNvPr id="330" name="Google Shape;330;g39421e1b5d2_0_0:notes"/>
           <p:cNvSpPr/>
           <p:nvPr>
             <p:ph idx="2" type="sldImg"/>
@@ -4303,7 +4303,7 @@
   <p:cSld>
     <p:spTree>
       <p:nvGrpSpPr>
-        <p:cNvPr id="332" name="Shape 332"/>
+        <p:cNvPr id="334" name="Shape 334"/>
         <p:cNvGrpSpPr/>
         <p:nvPr/>
       </p:nvGrpSpPr>
@@ -4317,7 +4317,7 @@
       </p:grpSpPr>
       <p:sp>
         <p:nvSpPr>
-          <p:cNvPr id="333" name="Google Shape;333;p38:notes"/>
+          <p:cNvPr id="335" name="Google Shape;335;p38:notes"/>
           <p:cNvSpPr txBox="1"/>
           <p:nvPr>
             <p:ph idx="1" type="body"/>
@@ -4356,7 +4356,7 @@
       </p:sp>
       <p:sp>
         <p:nvSpPr>
-          <p:cNvPr id="334" name="Google Shape;334;p38:notes"/>
+          <p:cNvPr id="336" name="Google Shape;336;p38:notes"/>
           <p:cNvSpPr/>
           <p:nvPr>
             <p:ph idx="2" type="sldImg"/>
@@ -4402,7 +4402,7 @@
   <p:cSld>
     <p:spTree>
       <p:nvGrpSpPr>
-        <p:cNvPr id="338" name="Shape 338"/>
+        <p:cNvPr id="340" name="Shape 340"/>
         <p:cNvGrpSpPr/>
         <p:nvPr/>
       </p:nvGrpSpPr>
@@ -4416,7 +4416,7 @@
       </p:grpSpPr>
       <p:sp>
         <p:nvSpPr>
-          <p:cNvPr id="339" name="Google Shape;339;p43:notes"/>
+          <p:cNvPr id="341" name="Google Shape;341;p43:notes"/>
           <p:cNvSpPr txBox="1"/>
           <p:nvPr>
             <p:ph idx="1" type="body"/>
@@ -4455,7 +4455,7 @@
       </p:sp>
       <p:sp>
         <p:nvSpPr>
-          <p:cNvPr id="340" name="Google Shape;340;p43:notes"/>
+          <p:cNvPr id="342" name="Google Shape;342;p43:notes"/>
           <p:cNvSpPr/>
           <p:nvPr>
             <p:ph idx="2" type="sldImg"/>
@@ -4501,7 +4501,7 @@
   <p:cSld>
     <p:spTree>
       <p:nvGrpSpPr>
-        <p:cNvPr id="343" name="Shape 343"/>
+        <p:cNvPr id="345" name="Shape 345"/>
         <p:cNvGrpSpPr/>
         <p:nvPr/>
       </p:nvGrpSpPr>
@@ -4515,7 +4515,7 @@
       </p:grpSpPr>
       <p:sp>
         <p:nvSpPr>
-          <p:cNvPr id="344" name="Google Shape;344;g3c9478fcecd_0_8:notes"/>
+          <p:cNvPr id="346" name="Google Shape;346;g3c9478fcecd_0_8:notes"/>
           <p:cNvSpPr/>
           <p:nvPr>
             <p:ph idx="2" type="sldImg"/>
@@ -4550,7 +4550,7 @@
       </p:sp>
       <p:sp>
         <p:nvSpPr>
-          <p:cNvPr id="345" name="Google Shape;345;g3c9478fcecd_0_8:notes"/>
+          <p:cNvPr id="347" name="Google Shape;347;g3c9478fcecd_0_8:notes"/>
           <p:cNvSpPr txBox="1"/>
           <p:nvPr>
             <p:ph idx="1" type="body"/>
@@ -4600,7 +4600,7 @@
   <p:cSld>
     <p:spTree>
       <p:nvGrpSpPr>
-        <p:cNvPr id="348" name="Shape 348"/>
+        <p:cNvPr id="350" name="Shape 350"/>
         <p:cNvGrpSpPr/>
         <p:nvPr/>
       </p:nvGrpSpPr>
@@ -4614,7 +4614,7 @@
       </p:grpSpPr>
       <p:sp>
         <p:nvSpPr>
-          <p:cNvPr id="349" name="Google Shape;349;p51:notes"/>
+          <p:cNvPr id="351" name="Google Shape;351;p51:notes"/>
           <p:cNvSpPr txBox="1"/>
           <p:nvPr>
             <p:ph idx="1" type="body"/>
@@ -4653,7 +4653,7 @@
       </p:sp>
       <p:sp>
         <p:nvSpPr>
-          <p:cNvPr id="350" name="Google Shape;350;p51:notes"/>
+          <p:cNvPr id="352" name="Google Shape;352;p51:notes"/>
           <p:cNvSpPr/>
           <p:nvPr>
             <p:ph idx="2" type="sldImg"/>
@@ -4699,7 +4699,7 @@
   <p:cSld>
     <p:spTree>
       <p:nvGrpSpPr>
-        <p:cNvPr id="353" name="Shape 353"/>
+        <p:cNvPr id="355" name="Shape 355"/>
         <p:cNvGrpSpPr/>
         <p:nvPr/>
       </p:nvGrpSpPr>
@@ -4713,7 +4713,7 @@
       </p:grpSpPr>
       <p:sp>
         <p:nvSpPr>
-          <p:cNvPr id="354" name="Google Shape;354;p57:notes"/>
+          <p:cNvPr id="356" name="Google Shape;356;p57:notes"/>
           <p:cNvSpPr txBox="1"/>
           <p:nvPr>
             <p:ph idx="1" type="body"/>
@@ -4752,7 +4752,7 @@
       </p:sp>
       <p:sp>
         <p:nvSpPr>
-          <p:cNvPr id="355" name="Google Shape;355;p57:notes"/>
+          <p:cNvPr id="357" name="Google Shape;357;p57:notes"/>
           <p:cNvSpPr/>
           <p:nvPr>
             <p:ph idx="2" type="sldImg"/>
@@ -4897,7 +4897,7 @@
   <p:cSld>
     <p:spTree>
       <p:nvGrpSpPr>
-        <p:cNvPr id="112" name="Shape 112"/>
+        <p:cNvPr id="114" name="Shape 114"/>
         <p:cNvGrpSpPr/>
         <p:nvPr/>
       </p:nvGrpSpPr>
@@ -4911,7 +4911,7 @@
       </p:grpSpPr>
       <p:sp>
         <p:nvSpPr>
-          <p:cNvPr id="113" name="Google Shape;113;p6:notes"/>
+          <p:cNvPr id="115" name="Google Shape;115;p6:notes"/>
           <p:cNvSpPr txBox="1"/>
           <p:nvPr>
             <p:ph idx="1" type="body"/>
@@ -4950,7 +4950,7 @@
       </p:sp>
       <p:sp>
         <p:nvSpPr>
-          <p:cNvPr id="114" name="Google Shape;114;p6:notes"/>
+          <p:cNvPr id="116" name="Google Shape;116;p6:notes"/>
           <p:cNvSpPr/>
           <p:nvPr>
             <p:ph idx="2" type="sldImg"/>
@@ -4996,7 +4996,7 @@
   <p:cSld>
     <p:spTree>
       <p:nvGrpSpPr>
-        <p:cNvPr id="119" name="Shape 119"/>
+        <p:cNvPr id="121" name="Shape 121"/>
         <p:cNvGrpSpPr/>
         <p:nvPr/>
       </p:nvGrpSpPr>
@@ -5010,7 +5010,7 @@
       </p:grpSpPr>
       <p:sp>
         <p:nvSpPr>
-          <p:cNvPr id="120" name="Google Shape;120;p7:notes"/>
+          <p:cNvPr id="122" name="Google Shape;122;p7:notes"/>
           <p:cNvSpPr txBox="1"/>
           <p:nvPr>
             <p:ph idx="1" type="body"/>
@@ -5049,7 +5049,7 @@
       </p:sp>
       <p:sp>
         <p:nvSpPr>
-          <p:cNvPr id="121" name="Google Shape;121;p7:notes"/>
+          <p:cNvPr id="123" name="Google Shape;123;p7:notes"/>
           <p:cNvSpPr/>
           <p:nvPr>
             <p:ph idx="2" type="sldImg"/>
@@ -5095,7 +5095,7 @@
   <p:cSld>
     <p:spTree>
       <p:nvGrpSpPr>
-        <p:cNvPr id="125" name="Shape 125"/>
+        <p:cNvPr id="127" name="Shape 127"/>
         <p:cNvGrpSpPr/>
         <p:nvPr/>
       </p:nvGrpSpPr>
@@ -5109,7 +5109,7 @@
       </p:grpSpPr>
       <p:sp>
         <p:nvSpPr>
-          <p:cNvPr id="126" name="Google Shape;126;p8:notes"/>
+          <p:cNvPr id="128" name="Google Shape;128;p8:notes"/>
           <p:cNvSpPr txBox="1"/>
           <p:nvPr>
             <p:ph idx="1" type="body"/>
@@ -5148,7 +5148,7 @@
       </p:sp>
       <p:sp>
         <p:nvSpPr>
-          <p:cNvPr id="127" name="Google Shape;127;p8:notes"/>
+          <p:cNvPr id="129" name="Google Shape;129;p8:notes"/>
           <p:cNvSpPr/>
           <p:nvPr>
             <p:ph idx="2" type="sldImg"/>
@@ -5194,7 +5194,7 @@
   <p:cSld>
     <p:spTree>
       <p:nvGrpSpPr>
-        <p:cNvPr id="131" name="Shape 131"/>
+        <p:cNvPr id="133" name="Shape 133"/>
         <p:cNvGrpSpPr/>
         <p:nvPr/>
       </p:nvGrpSpPr>
@@ -5208,7 +5208,7 @@
       </p:grpSpPr>
       <p:sp>
         <p:nvSpPr>
-          <p:cNvPr id="132" name="Google Shape;132;p9:notes"/>
+          <p:cNvPr id="134" name="Google Shape;134;p9:notes"/>
           <p:cNvSpPr txBox="1"/>
           <p:nvPr>
             <p:ph idx="1" type="body"/>
@@ -5247,7 +5247,7 @@
       </p:sp>
       <p:sp>
         <p:nvSpPr>
-          <p:cNvPr id="133" name="Google Shape;133;p9:notes"/>
+          <p:cNvPr id="135" name="Google Shape;135;p9:notes"/>
           <p:cNvSpPr/>
           <p:nvPr>
             <p:ph idx="2" type="sldImg"/>
@@ -15344,7 +15344,7 @@
   <p:cSld>
     <p:spTree>
       <p:nvGrpSpPr>
-        <p:cNvPr id="140" name="Shape 140"/>
+        <p:cNvPr id="142" name="Shape 142"/>
         <p:cNvGrpSpPr/>
         <p:nvPr/>
       </p:nvGrpSpPr>
@@ -15358,7 +15358,7 @@
       </p:grpSpPr>
       <p:sp>
         <p:nvSpPr>
-          <p:cNvPr id="141" name="Google Shape;141;p10"/>
+          <p:cNvPr id="143" name="Google Shape;143;p10"/>
           <p:cNvSpPr txBox="1"/>
           <p:nvPr/>
         </p:nvSpPr>
@@ -15408,7 +15408,7 @@
       </p:sp>
       <p:sp>
         <p:nvSpPr>
-          <p:cNvPr id="142" name="Google Shape;142;p10"/>
+          <p:cNvPr id="144" name="Google Shape;144;p10"/>
           <p:cNvSpPr txBox="1"/>
           <p:nvPr/>
         </p:nvSpPr>
@@ -15824,7 +15824,7 @@
   <p:cSld>
     <p:spTree>
       <p:nvGrpSpPr>
-        <p:cNvPr id="146" name="Shape 146"/>
+        <p:cNvPr id="148" name="Shape 148"/>
         <p:cNvGrpSpPr/>
         <p:nvPr/>
       </p:nvGrpSpPr>
@@ -15838,7 +15838,7 @@
       </p:grpSpPr>
       <p:sp>
         <p:nvSpPr>
-          <p:cNvPr id="147" name="Google Shape;147;p11"/>
+          <p:cNvPr id="149" name="Google Shape;149;p11"/>
           <p:cNvSpPr txBox="1"/>
           <p:nvPr/>
         </p:nvSpPr>
@@ -15888,7 +15888,7 @@
       </p:sp>
       <p:sp>
         <p:nvSpPr>
-          <p:cNvPr id="148" name="Google Shape;148;p11"/>
+          <p:cNvPr id="150" name="Google Shape;150;p11"/>
           <p:cNvSpPr txBox="1"/>
           <p:nvPr/>
         </p:nvSpPr>
@@ -16409,7 +16409,7 @@
       </p:sp>
       <p:pic>
         <p:nvPicPr>
-          <p:cNvPr id="149" name="Google Shape;149;p11"/>
+          <p:cNvPr id="151" name="Google Shape;151;p11"/>
           <p:cNvPicPr preferRelativeResize="0"/>
           <p:nvPr/>
         </p:nvPicPr>
@@ -16448,7 +16448,7 @@
   <p:cSld>
     <p:spTree>
       <p:nvGrpSpPr>
-        <p:cNvPr id="153" name="Shape 153"/>
+        <p:cNvPr id="155" name="Shape 155"/>
         <p:cNvGrpSpPr/>
         <p:nvPr/>
       </p:nvGrpSpPr>
@@ -16462,7 +16462,7 @@
       </p:grpSpPr>
       <p:pic>
         <p:nvPicPr>
-          <p:cNvPr id="154" name="Google Shape;154;g394273392e2_0_19"/>
+          <p:cNvPr id="156" name="Google Shape;156;g394273392e2_0_19"/>
           <p:cNvPicPr preferRelativeResize="0"/>
           <p:nvPr/>
         </p:nvPicPr>
@@ -16490,7 +16490,7 @@
       </p:pic>
       <p:pic>
         <p:nvPicPr>
-          <p:cNvPr id="155" name="Google Shape;155;g394273392e2_0_19"/>
+          <p:cNvPr id="157" name="Google Shape;157;g394273392e2_0_19"/>
           <p:cNvPicPr preferRelativeResize="0"/>
           <p:nvPr/>
         </p:nvPicPr>
@@ -16529,7 +16529,7 @@
   <p:cSld>
     <p:spTree>
       <p:nvGrpSpPr>
-        <p:cNvPr id="159" name="Shape 159"/>
+        <p:cNvPr id="161" name="Shape 161"/>
         <p:cNvGrpSpPr/>
         <p:nvPr/>
       </p:nvGrpSpPr>
@@ -16543,7 +16543,453 @@
       </p:grpSpPr>
       <p:sp>
         <p:nvSpPr>
-          <p:cNvPr id="160" name="Google Shape;160;p12"/>
+          <p:cNvPr id="162" name="Google Shape;162;p12"/>
+          <p:cNvSpPr txBox="1"/>
+          <p:nvPr/>
+        </p:nvSpPr>
+        <p:spPr>
+          <a:xfrm>
+            <a:off x="457200" y="274320"/>
+            <a:ext cx="8229600" cy="523200"/>
+          </a:xfrm>
+          <a:prstGeom prst="rect">
+            <a:avLst/>
+          </a:prstGeom>
+          <a:noFill/>
+          <a:ln>
+            <a:noFill/>
+          </a:ln>
+        </p:spPr>
+        <p:txBody>
+          <a:bodyPr anchorCtr="0" anchor="t" bIns="45700" lIns="91425" spcFirstLastPara="1" rIns="91425" wrap="square" tIns="45700">
+            <a:spAutoFit/>
+          </a:bodyPr>
+          <a:lstStyle/>
+          <a:p>
+            <a:pPr indent="0" lvl="0" marL="0" marR="0" rtl="0" algn="l">
+              <a:spcBef>
+                <a:spcPts val="0"/>
+              </a:spcBef>
+              <a:spcAft>
+                <a:spcPts val="0"/>
+              </a:spcAft>
+              <a:buNone/>
+            </a:pPr>
+            <a:r>
+              <a:rPr b="1" lang="en-US" sz="2800">
+                <a:solidFill>
+                  <a:srgbClr val="003366"/>
+                </a:solidFill>
+                <a:latin typeface="Calibri"/>
+                <a:ea typeface="Calibri"/>
+                <a:cs typeface="Calibri"/>
+                <a:sym typeface="Calibri"/>
+              </a:rPr>
+              <a:t>Pre-training de BERT </a:t>
+            </a:r>
+            <a:r>
+              <a:rPr lang="en-US" sz="1600">
+                <a:solidFill>
+                  <a:schemeClr val="dk1"/>
+                </a:solidFill>
+                <a:latin typeface="Calibri"/>
+                <a:ea typeface="Calibri"/>
+                <a:cs typeface="Calibri"/>
+                <a:sym typeface="Calibri"/>
+              </a:rPr>
+              <a:t>(Google, 2018)</a:t>
+            </a:r>
+            <a:endParaRPr/>
+          </a:p>
+        </p:txBody>
+      </p:sp>
+      <p:sp>
+        <p:nvSpPr>
+          <p:cNvPr id="163" name="Google Shape;163;p12"/>
+          <p:cNvSpPr txBox="1"/>
+          <p:nvPr/>
+        </p:nvSpPr>
+        <p:spPr>
+          <a:xfrm>
+            <a:off x="457200" y="943345"/>
+            <a:ext cx="8229600" cy="4874100"/>
+          </a:xfrm>
+          <a:prstGeom prst="rect">
+            <a:avLst/>
+          </a:prstGeom>
+          <a:noFill/>
+          <a:ln>
+            <a:noFill/>
+          </a:ln>
+        </p:spPr>
+        <p:txBody>
+          <a:bodyPr anchorCtr="0" anchor="t" bIns="45700" lIns="91425" spcFirstLastPara="1" rIns="91425" wrap="square" tIns="45700">
+            <a:spAutoFit/>
+          </a:bodyPr>
+          <a:lstStyle/>
+          <a:p>
+            <a:pPr indent="0" lvl="0" marL="0" marR="0" rtl="0" algn="l">
+              <a:spcBef>
+                <a:spcPts val="0"/>
+              </a:spcBef>
+              <a:spcAft>
+                <a:spcPts val="0"/>
+              </a:spcAft>
+              <a:buNone/>
+            </a:pPr>
+            <a:r>
+              <a:rPr lang="en-US" sz="1600">
+                <a:solidFill>
+                  <a:schemeClr val="dk1"/>
+                </a:solidFill>
+                <a:latin typeface="Calibri"/>
+                <a:ea typeface="Calibri"/>
+                <a:cs typeface="Calibri"/>
+                <a:sym typeface="Calibri"/>
+              </a:rPr>
+              <a:t>DOS TAREAS DE PRE-ENTRENAMIENTO NO SUPERVISADO:</a:t>
+            </a:r>
+            <a:endParaRPr/>
+          </a:p>
+          <a:p>
+            <a:pPr indent="0" lvl="0" marL="0" marR="0" rtl="0" algn="l">
+              <a:spcBef>
+                <a:spcPts val="800"/>
+              </a:spcBef>
+              <a:spcAft>
+                <a:spcPts val="0"/>
+              </a:spcAft>
+              <a:buNone/>
+            </a:pPr>
+            <a:r>
+              <a:t/>
+            </a:r>
+            <a:endParaRPr sz="1600">
+              <a:solidFill>
+                <a:schemeClr val="dk1"/>
+              </a:solidFill>
+              <a:latin typeface="Calibri"/>
+              <a:ea typeface="Calibri"/>
+              <a:cs typeface="Calibri"/>
+              <a:sym typeface="Calibri"/>
+            </a:endParaRPr>
+          </a:p>
+          <a:p>
+            <a:pPr indent="0" lvl="0" marL="0" marR="0" rtl="0" algn="l">
+              <a:spcBef>
+                <a:spcPts val="800"/>
+              </a:spcBef>
+              <a:spcAft>
+                <a:spcPts val="0"/>
+              </a:spcAft>
+              <a:buNone/>
+            </a:pPr>
+            <a:r>
+              <a:rPr lang="en-US" sz="1600">
+                <a:solidFill>
+                  <a:schemeClr val="dk1"/>
+                </a:solidFill>
+                <a:latin typeface="Calibri"/>
+                <a:ea typeface="Calibri"/>
+                <a:cs typeface="Calibri"/>
+                <a:sym typeface="Calibri"/>
+              </a:rPr>
+              <a:t>1. MASKED LANGUAGE MODEL (MLM):</a:t>
+            </a:r>
+            <a:endParaRPr/>
+          </a:p>
+          <a:p>
+            <a:pPr indent="0" lvl="0" marL="0" marR="0" rtl="0" algn="l">
+              <a:spcBef>
+                <a:spcPts val="800"/>
+              </a:spcBef>
+              <a:spcAft>
+                <a:spcPts val="0"/>
+              </a:spcAft>
+              <a:buNone/>
+            </a:pPr>
+            <a:r>
+              <a:rPr lang="en-US" sz="1600">
+                <a:solidFill>
+                  <a:schemeClr val="dk1"/>
+                </a:solidFill>
+                <a:latin typeface="Calibri"/>
+                <a:ea typeface="Calibri"/>
+                <a:cs typeface="Calibri"/>
+                <a:sym typeface="Calibri"/>
+              </a:rPr>
+              <a:t>   • 15% de tokens se enmascaran aleatoriamente con [MASK]</a:t>
+            </a:r>
+            <a:endParaRPr/>
+          </a:p>
+          <a:p>
+            <a:pPr indent="0" lvl="0" marL="0" marR="0" rtl="0" algn="l">
+              <a:spcBef>
+                <a:spcPts val="800"/>
+              </a:spcBef>
+              <a:spcAft>
+                <a:spcPts val="0"/>
+              </a:spcAft>
+              <a:buNone/>
+            </a:pPr>
+            <a:r>
+              <a:rPr lang="en-US" sz="1600">
+                <a:solidFill>
+                  <a:schemeClr val="dk1"/>
+                </a:solidFill>
+                <a:latin typeface="Calibri"/>
+                <a:ea typeface="Calibri"/>
+                <a:cs typeface="Calibri"/>
+                <a:sym typeface="Calibri"/>
+              </a:rPr>
+              <a:t>   • Objetivo: predecir los tokens enmascarados usando contexto bidireccional</a:t>
+            </a:r>
+            <a:endParaRPr/>
+          </a:p>
+          <a:p>
+            <a:pPr indent="0" lvl="0" marL="0" marR="0" rtl="0" algn="l">
+              <a:spcBef>
+                <a:spcPts val="800"/>
+              </a:spcBef>
+              <a:spcAft>
+                <a:spcPts val="0"/>
+              </a:spcAft>
+              <a:buNone/>
+            </a:pPr>
+            <a:r>
+              <a:rPr lang="en-US" sz="1600">
+                <a:solidFill>
+                  <a:schemeClr val="dk1"/>
+                </a:solidFill>
+                <a:latin typeface="Calibri"/>
+                <a:ea typeface="Calibri"/>
+                <a:cs typeface="Calibri"/>
+                <a:sym typeface="Calibri"/>
+              </a:rPr>
+              <a:t>   • Ejemplo: 'El [MASK] come pescado' → predecir 'gato'</a:t>
+            </a:r>
+            <a:endParaRPr/>
+          </a:p>
+          <a:p>
+            <a:pPr indent="0" lvl="0" marL="0" marR="0" rtl="0" algn="l">
+              <a:spcBef>
+                <a:spcPts val="800"/>
+              </a:spcBef>
+              <a:spcAft>
+                <a:spcPts val="0"/>
+              </a:spcAft>
+              <a:buNone/>
+            </a:pPr>
+            <a:r>
+              <a:rPr lang="en-US" sz="1600">
+                <a:solidFill>
+                  <a:schemeClr val="dk1"/>
+                </a:solidFill>
+                <a:latin typeface="Calibri"/>
+                <a:ea typeface="Calibri"/>
+                <a:cs typeface="Calibri"/>
+                <a:sym typeface="Calibri"/>
+              </a:rPr>
+              <a:t>   • Aprende representaciones contextuales profundas</a:t>
+            </a:r>
+            <a:endParaRPr/>
+          </a:p>
+          <a:p>
+            <a:pPr indent="0" lvl="0" marL="0" marR="0" rtl="0" algn="l">
+              <a:spcBef>
+                <a:spcPts val="800"/>
+              </a:spcBef>
+              <a:spcAft>
+                <a:spcPts val="0"/>
+              </a:spcAft>
+              <a:buNone/>
+            </a:pPr>
+            <a:r>
+              <a:t/>
+            </a:r>
+            <a:endParaRPr sz="1600">
+              <a:solidFill>
+                <a:schemeClr val="dk1"/>
+              </a:solidFill>
+              <a:latin typeface="Calibri"/>
+              <a:ea typeface="Calibri"/>
+              <a:cs typeface="Calibri"/>
+              <a:sym typeface="Calibri"/>
+            </a:endParaRPr>
+          </a:p>
+          <a:p>
+            <a:pPr indent="0" lvl="0" marL="0" marR="0" rtl="0" algn="l">
+              <a:spcBef>
+                <a:spcPts val="800"/>
+              </a:spcBef>
+              <a:spcAft>
+                <a:spcPts val="0"/>
+              </a:spcAft>
+              <a:buNone/>
+            </a:pPr>
+            <a:r>
+              <a:rPr lang="en-US" sz="1600">
+                <a:solidFill>
+                  <a:schemeClr val="dk1"/>
+                </a:solidFill>
+                <a:latin typeface="Calibri"/>
+                <a:ea typeface="Calibri"/>
+                <a:cs typeface="Calibri"/>
+                <a:sym typeface="Calibri"/>
+              </a:rPr>
+              <a:t>2. NEXT SENTENCE PREDICTION (NSP):</a:t>
+            </a:r>
+            <a:endParaRPr/>
+          </a:p>
+          <a:p>
+            <a:pPr indent="0" lvl="0" marL="0" marR="0" rtl="0" algn="l">
+              <a:spcBef>
+                <a:spcPts val="800"/>
+              </a:spcBef>
+              <a:spcAft>
+                <a:spcPts val="0"/>
+              </a:spcAft>
+              <a:buNone/>
+            </a:pPr>
+            <a:r>
+              <a:rPr lang="en-US" sz="1600">
+                <a:solidFill>
+                  <a:schemeClr val="dk1"/>
+                </a:solidFill>
+                <a:latin typeface="Calibri"/>
+                <a:ea typeface="Calibri"/>
+                <a:cs typeface="Calibri"/>
+                <a:sym typeface="Calibri"/>
+              </a:rPr>
+              <a:t>   • Par de oraciones (A, B)</a:t>
+            </a:r>
+            <a:endParaRPr/>
+          </a:p>
+          <a:p>
+            <a:pPr indent="0" lvl="0" marL="0" marR="0" rtl="0" algn="l">
+              <a:spcBef>
+                <a:spcPts val="800"/>
+              </a:spcBef>
+              <a:spcAft>
+                <a:spcPts val="0"/>
+              </a:spcAft>
+              <a:buNone/>
+            </a:pPr>
+            <a:r>
+              <a:rPr lang="en-US" sz="1600">
+                <a:solidFill>
+                  <a:schemeClr val="dk1"/>
+                </a:solidFill>
+                <a:latin typeface="Calibri"/>
+                <a:ea typeface="Calibri"/>
+                <a:cs typeface="Calibri"/>
+                <a:sym typeface="Calibri"/>
+              </a:rPr>
+              <a:t>   • Objetivo: clasificar si B sigue a A (binario)</a:t>
+            </a:r>
+            <a:endParaRPr/>
+          </a:p>
+          <a:p>
+            <a:pPr indent="0" lvl="0" marL="0" marR="0" rtl="0" algn="l">
+              <a:spcBef>
+                <a:spcPts val="800"/>
+              </a:spcBef>
+              <a:spcAft>
+                <a:spcPts val="0"/>
+              </a:spcAft>
+              <a:buNone/>
+            </a:pPr>
+            <a:r>
+              <a:rPr lang="en-US" sz="1600">
+                <a:solidFill>
+                  <a:schemeClr val="dk1"/>
+                </a:solidFill>
+                <a:latin typeface="Calibri"/>
+                <a:ea typeface="Calibri"/>
+                <a:cs typeface="Calibri"/>
+                <a:sym typeface="Calibri"/>
+              </a:rPr>
+              <a:t>   • Aprende relaciones inter-oracionales</a:t>
+            </a:r>
+            <a:endParaRPr/>
+          </a:p>
+          <a:p>
+            <a:pPr indent="0" lvl="0" marL="0" marR="0" rtl="0" algn="l">
+              <a:spcBef>
+                <a:spcPts val="800"/>
+              </a:spcBef>
+              <a:spcAft>
+                <a:spcPts val="0"/>
+              </a:spcAft>
+              <a:buNone/>
+            </a:pPr>
+            <a:r>
+              <a:t/>
+            </a:r>
+            <a:endParaRPr sz="1600">
+              <a:solidFill>
+                <a:schemeClr val="dk1"/>
+              </a:solidFill>
+              <a:latin typeface="Calibri"/>
+              <a:ea typeface="Calibri"/>
+              <a:cs typeface="Calibri"/>
+              <a:sym typeface="Calibri"/>
+            </a:endParaRPr>
+          </a:p>
+          <a:p>
+            <a:pPr indent="0" lvl="0" marL="0" marR="0" rtl="0" algn="l">
+              <a:spcBef>
+                <a:spcPts val="800"/>
+              </a:spcBef>
+              <a:spcAft>
+                <a:spcPts val="0"/>
+              </a:spcAft>
+              <a:buNone/>
+            </a:pPr>
+            <a:r>
+              <a:rPr lang="en-US" sz="1600">
+                <a:solidFill>
+                  <a:schemeClr val="dk1"/>
+                </a:solidFill>
+                <a:latin typeface="Calibri"/>
+                <a:ea typeface="Calibri"/>
+                <a:cs typeface="Calibri"/>
+                <a:sym typeface="Calibri"/>
+              </a:rPr>
+              <a:t>Dataset: BooksCorpus (800M palabras) + Wikipedia inglesa (2,500M palabras)</a:t>
+            </a:r>
+            <a:endParaRPr/>
+          </a:p>
+        </p:txBody>
+      </p:sp>
+    </p:spTree>
+  </p:cSld>
+  <p:clrMapOvr>
+    <a:masterClrMapping/>
+  </p:clrMapOvr>
+</p:sld>
+</file>
+
+<file path=ppt/slides/slide14.xml><?xml version="1.0" encoding="utf-8"?>
+<p:sld xmlns:a="http://schemas.openxmlformats.org/drawingml/2006/main" xmlns:r="http://schemas.openxmlformats.org/officeDocument/2006/relationships" xmlns:mc="http://schemas.openxmlformats.org/markup-compatibility/2006" xmlns:mv="urn:schemas-microsoft-com:mac:vml" xmlns:p="http://schemas.openxmlformats.org/presentationml/2006/main" xmlns:c="http://schemas.openxmlformats.org/drawingml/2006/chart" xmlns:dgm="http://schemas.openxmlformats.org/drawingml/2006/diagram" xmlns:o="urn:schemas-microsoft-com:office:office" xmlns:v="urn:schemas-microsoft-com:vml" xmlns:pvml="urn:schemas-microsoft-com:office:powerpoint" xmlns:com="http://schemas.openxmlformats.org/drawingml/2006/compatibility" xmlns:p14="http://schemas.microsoft.com/office/powerpoint/2010/main" xmlns:p15="http://schemas.microsoft.com/office/powerpoint/2012/main" xmlns:ahyp="http://schemas.microsoft.com/office/drawing/2018/hyperlinkcolor">
+  <p:cSld>
+    <p:spTree>
+      <p:nvGrpSpPr>
+        <p:cNvPr id="167" name="Shape 167"/>
+        <p:cNvGrpSpPr/>
+        <p:nvPr/>
+      </p:nvGrpSpPr>
+      <p:grpSpPr>
+        <a:xfrm>
+          <a:off x="0" y="0"/>
+          <a:ext cx="0" cy="0"/>
+          <a:chOff x="0" y="0"/>
+          <a:chExt cx="0" cy="0"/>
+        </a:xfrm>
+      </p:grpSpPr>
+      <p:sp>
+        <p:nvSpPr>
+          <p:cNvPr id="168" name="Google Shape;168;p13"/>
           <p:cNvSpPr txBox="1"/>
           <p:nvPr/>
         </p:nvSpPr>
@@ -16585,7 +17031,7 @@
                 <a:cs typeface="Calibri"/>
                 <a:sym typeface="Calibri"/>
               </a:rPr>
-              <a:t>Pre-training de BERT</a:t>
+              <a:t>Fine-Tuning de BERT</a:t>
             </a:r>
             <a:endParaRPr/>
           </a:p>
@@ -16593,14 +17039,14 @@
       </p:sp>
       <p:sp>
         <p:nvSpPr>
-          <p:cNvPr id="161" name="Google Shape;161;p12"/>
+          <p:cNvPr id="169" name="Google Shape;169;p13"/>
           <p:cNvSpPr txBox="1"/>
           <p:nvPr/>
         </p:nvSpPr>
         <p:spPr>
           <a:xfrm>
-            <a:off x="457200" y="1188720"/>
-            <a:ext cx="8229600" cy="5571900"/>
+            <a:off x="418450" y="956220"/>
+            <a:ext cx="8229600" cy="3827400"/>
           </a:xfrm>
           <a:prstGeom prst="rect">
             <a:avLst/>
@@ -16618,7 +17064,7 @@
           <a:p>
             <a:pPr indent="0" lvl="0" marL="0" marR="0" rtl="0" algn="l">
               <a:spcBef>
-                <a:spcPts val="0"/>
+                <a:spcPts val="800"/>
               </a:spcBef>
               <a:spcAft>
                 <a:spcPts val="0"/>
@@ -16635,7 +17081,103 @@
                 <a:cs typeface="Calibri"/>
                 <a:sym typeface="Calibri"/>
               </a:rPr>
-              <a:t>PRE-TRAINING DE BERT (Google, 2018):</a:t>
+              <a:t>VENTAJAS DE TRANSFER LEARNING:</a:t>
+            </a:r>
+            <a:endParaRPr/>
+          </a:p>
+          <a:p>
+            <a:pPr indent="0" lvl="0" marL="0" marR="0" rtl="0" algn="l">
+              <a:spcBef>
+                <a:spcPts val="800"/>
+              </a:spcBef>
+              <a:spcAft>
+                <a:spcPts val="0"/>
+              </a:spcAft>
+              <a:buNone/>
+            </a:pPr>
+            <a:r>
+              <a:rPr lang="en-US" sz="1600">
+                <a:solidFill>
+                  <a:schemeClr val="dk1"/>
+                </a:solidFill>
+                <a:latin typeface="Calibri"/>
+                <a:ea typeface="Calibri"/>
+                <a:cs typeface="Calibri"/>
+                <a:sym typeface="Calibri"/>
+              </a:rPr>
+              <a:t>• Aprovecha conocimiento lingüístico general del pre-training</a:t>
+            </a:r>
+            <a:endParaRPr/>
+          </a:p>
+          <a:p>
+            <a:pPr indent="0" lvl="0" marL="0" marR="0" rtl="0" algn="l">
+              <a:spcBef>
+                <a:spcPts val="800"/>
+              </a:spcBef>
+              <a:spcAft>
+                <a:spcPts val="0"/>
+              </a:spcAft>
+              <a:buNone/>
+            </a:pPr>
+            <a:r>
+              <a:rPr lang="en-US" sz="1600">
+                <a:solidFill>
+                  <a:schemeClr val="dk1"/>
+                </a:solidFill>
+                <a:latin typeface="Calibri"/>
+                <a:ea typeface="Calibri"/>
+                <a:cs typeface="Calibri"/>
+                <a:sym typeface="Calibri"/>
+              </a:rPr>
+              <a:t>• Requiere menos datos etiquetados que entrenar from scratch</a:t>
+            </a:r>
+            <a:endParaRPr/>
+          </a:p>
+          <a:p>
+            <a:pPr indent="0" lvl="0" marL="0" marR="0" rtl="0" algn="l">
+              <a:spcBef>
+                <a:spcPts val="800"/>
+              </a:spcBef>
+              <a:spcAft>
+                <a:spcPts val="0"/>
+              </a:spcAft>
+              <a:buNone/>
+            </a:pPr>
+            <a:r>
+              <a:rPr lang="en-US" sz="1600">
+                <a:solidFill>
+                  <a:schemeClr val="dk1"/>
+                </a:solidFill>
+                <a:latin typeface="Calibri"/>
+                <a:ea typeface="Calibri"/>
+                <a:cs typeface="Calibri"/>
+                <a:sym typeface="Calibri"/>
+              </a:rPr>
+              <a:t>• Mejor performance y convergencia más rápida</a:t>
+            </a:r>
+            <a:endParaRPr/>
+          </a:p>
+          <a:p>
+            <a:pPr indent="0" lvl="0" marL="0" marR="0" rtl="0" algn="l">
+              <a:spcBef>
+                <a:spcPts val="800"/>
+              </a:spcBef>
+              <a:spcAft>
+                <a:spcPts val="0"/>
+              </a:spcAft>
+              <a:buNone/>
+            </a:pPr>
+            <a:r>
+              <a:rPr lang="en-US" sz="1600">
+                <a:solidFill>
+                  <a:schemeClr val="dk1"/>
+                </a:solidFill>
+                <a:latin typeface="Calibri"/>
+                <a:ea typeface="Calibri"/>
+                <a:cs typeface="Calibri"/>
+                <a:sym typeface="Calibri"/>
+              </a:rPr>
+              <a:t>• Generaliza mejor en dominios específicos</a:t>
             </a:r>
             <a:endParaRPr/>
           </a:p>
@@ -16682,32 +17224,9 @@
                 <a:cs typeface="Calibri"/>
                 <a:sym typeface="Calibri"/>
               </a:rPr>
-              <a:t>DOS TAREAS DE PRE-ENTRENAMIENTO NO SUPERVISADO:</a:t>
-            </a:r>
-            <a:endParaRPr/>
-          </a:p>
-          <a:p>
-            <a:pPr indent="0" lvl="0" marL="0" marR="0" rtl="0" algn="l">
-              <a:spcBef>
-                <a:spcPts val="800"/>
-              </a:spcBef>
-              <a:spcAft>
-                <a:spcPts val="0"/>
-              </a:spcAft>
-              <a:buNone/>
-            </a:pPr>
-            <a:r>
-              <a:t/>
-            </a:r>
-            <a:endParaRPr sz="1600">
-              <a:solidFill>
-                <a:schemeClr val="dk1"/>
-              </a:solidFill>
-              <a:latin typeface="Calibri"/>
-              <a:ea typeface="Calibri"/>
-              <a:cs typeface="Calibri"/>
-              <a:sym typeface="Calibri"/>
-            </a:endParaRPr>
+              <a:t>PROCESO:</a:t>
+            </a:r>
+            <a:endParaRPr/>
           </a:p>
           <a:p>
             <a:pPr indent="0" lvl="0" marL="0" marR="0" rtl="0" algn="l">
@@ -16729,7 +17248,7 @@
                 <a:cs typeface="Calibri"/>
                 <a:sym typeface="Calibri"/>
               </a:rPr>
-              <a:t>1. MASKED LANGUAGE MODEL (MLM):</a:t>
+              <a:t>1. Cargar BERT pre-entrenado (pesos de MLM + NSP)</a:t>
             </a:r>
             <a:endParaRPr/>
           </a:p>
@@ -16753,7 +17272,7 @@
                 <a:cs typeface="Calibri"/>
                 <a:sym typeface="Calibri"/>
               </a:rPr>
-              <a:t>   • 15% de tokens se enmascaran aleatoriamente con [MASK]</a:t>
+              <a:t>2. Agregar capa de clasificación task-specific (linear layer)</a:t>
             </a:r>
             <a:endParaRPr/>
           </a:p>
@@ -16777,7 +17296,7 @@
                 <a:cs typeface="Calibri"/>
                 <a:sym typeface="Calibri"/>
               </a:rPr>
-              <a:t>   • Objetivo: predecir los tokens enmascarados usando contexto bidireccional</a:t>
+              <a:t>3. Fine-tunear TODAS las capas (no solo la capa final)</a:t>
             </a:r>
             <a:endParaRPr/>
           </a:p>
@@ -16801,197 +17320,7 @@
                 <a:cs typeface="Calibri"/>
                 <a:sym typeface="Calibri"/>
               </a:rPr>
-              <a:t>   • Ejemplo: 'El [MASK] come pescado' → predecir 'gato'</a:t>
-            </a:r>
-            <a:endParaRPr/>
-          </a:p>
-          <a:p>
-            <a:pPr indent="0" lvl="0" marL="0" marR="0" rtl="0" algn="l">
-              <a:spcBef>
-                <a:spcPts val="800"/>
-              </a:spcBef>
-              <a:spcAft>
-                <a:spcPts val="0"/>
-              </a:spcAft>
-              <a:buNone/>
-            </a:pPr>
-            <a:r>
-              <a:rPr lang="en-US" sz="1600">
-                <a:solidFill>
-                  <a:schemeClr val="dk1"/>
-                </a:solidFill>
-                <a:latin typeface="Calibri"/>
-                <a:ea typeface="Calibri"/>
-                <a:cs typeface="Calibri"/>
-                <a:sym typeface="Calibri"/>
-              </a:rPr>
-              <a:t>   • Aprende representaciones contextuales profundas</a:t>
-            </a:r>
-            <a:endParaRPr/>
-          </a:p>
-          <a:p>
-            <a:pPr indent="0" lvl="0" marL="0" marR="0" rtl="0" algn="l">
-              <a:spcBef>
-                <a:spcPts val="800"/>
-              </a:spcBef>
-              <a:spcAft>
-                <a:spcPts val="0"/>
-              </a:spcAft>
-              <a:buNone/>
-            </a:pPr>
-            <a:r>
-              <a:t/>
-            </a:r>
-            <a:endParaRPr sz="1600">
-              <a:solidFill>
-                <a:schemeClr val="dk1"/>
-              </a:solidFill>
-              <a:latin typeface="Calibri"/>
-              <a:ea typeface="Calibri"/>
-              <a:cs typeface="Calibri"/>
-              <a:sym typeface="Calibri"/>
-            </a:endParaRPr>
-          </a:p>
-          <a:p>
-            <a:pPr indent="0" lvl="0" marL="0" marR="0" rtl="0" algn="l">
-              <a:spcBef>
-                <a:spcPts val="800"/>
-              </a:spcBef>
-              <a:spcAft>
-                <a:spcPts val="0"/>
-              </a:spcAft>
-              <a:buNone/>
-            </a:pPr>
-            <a:r>
-              <a:rPr lang="en-US" sz="1600">
-                <a:solidFill>
-                  <a:schemeClr val="dk1"/>
-                </a:solidFill>
-                <a:latin typeface="Calibri"/>
-                <a:ea typeface="Calibri"/>
-                <a:cs typeface="Calibri"/>
-                <a:sym typeface="Calibri"/>
-              </a:rPr>
-              <a:t>2. NEXT SENTENCE PREDICTION (NSP):</a:t>
-            </a:r>
-            <a:endParaRPr/>
-          </a:p>
-          <a:p>
-            <a:pPr indent="0" lvl="0" marL="0" marR="0" rtl="0" algn="l">
-              <a:spcBef>
-                <a:spcPts val="800"/>
-              </a:spcBef>
-              <a:spcAft>
-                <a:spcPts val="0"/>
-              </a:spcAft>
-              <a:buNone/>
-            </a:pPr>
-            <a:r>
-              <a:rPr lang="en-US" sz="1600">
-                <a:solidFill>
-                  <a:schemeClr val="dk1"/>
-                </a:solidFill>
-                <a:latin typeface="Calibri"/>
-                <a:ea typeface="Calibri"/>
-                <a:cs typeface="Calibri"/>
-                <a:sym typeface="Calibri"/>
-              </a:rPr>
-              <a:t>   • Par de oraciones (A, B)</a:t>
-            </a:r>
-            <a:endParaRPr/>
-          </a:p>
-          <a:p>
-            <a:pPr indent="0" lvl="0" marL="0" marR="0" rtl="0" algn="l">
-              <a:spcBef>
-                <a:spcPts val="800"/>
-              </a:spcBef>
-              <a:spcAft>
-                <a:spcPts val="0"/>
-              </a:spcAft>
-              <a:buNone/>
-            </a:pPr>
-            <a:r>
-              <a:rPr lang="en-US" sz="1600">
-                <a:solidFill>
-                  <a:schemeClr val="dk1"/>
-                </a:solidFill>
-                <a:latin typeface="Calibri"/>
-                <a:ea typeface="Calibri"/>
-                <a:cs typeface="Calibri"/>
-                <a:sym typeface="Calibri"/>
-              </a:rPr>
-              <a:t>   • Objetivo: clasificar si B sigue a A (binario)</a:t>
-            </a:r>
-            <a:endParaRPr/>
-          </a:p>
-          <a:p>
-            <a:pPr indent="0" lvl="0" marL="0" marR="0" rtl="0" algn="l">
-              <a:spcBef>
-                <a:spcPts val="800"/>
-              </a:spcBef>
-              <a:spcAft>
-                <a:spcPts val="0"/>
-              </a:spcAft>
-              <a:buNone/>
-            </a:pPr>
-            <a:r>
-              <a:rPr lang="en-US" sz="1600">
-                <a:solidFill>
-                  <a:schemeClr val="dk1"/>
-                </a:solidFill>
-                <a:latin typeface="Calibri"/>
-                <a:ea typeface="Calibri"/>
-                <a:cs typeface="Calibri"/>
-                <a:sym typeface="Calibri"/>
-              </a:rPr>
-              <a:t>   • Aprende relaciones inter-oracionales</a:t>
-            </a:r>
-            <a:endParaRPr/>
-          </a:p>
-          <a:p>
-            <a:pPr indent="0" lvl="0" marL="0" marR="0" rtl="0" algn="l">
-              <a:spcBef>
-                <a:spcPts val="800"/>
-              </a:spcBef>
-              <a:spcAft>
-                <a:spcPts val="0"/>
-              </a:spcAft>
-              <a:buNone/>
-            </a:pPr>
-            <a:r>
-              <a:t/>
-            </a:r>
-            <a:endParaRPr sz="1600">
-              <a:solidFill>
-                <a:schemeClr val="dk1"/>
-              </a:solidFill>
-              <a:latin typeface="Calibri"/>
-              <a:ea typeface="Calibri"/>
-              <a:cs typeface="Calibri"/>
-              <a:sym typeface="Calibri"/>
-            </a:endParaRPr>
-          </a:p>
-          <a:p>
-            <a:pPr indent="0" lvl="0" marL="0" marR="0" rtl="0" algn="l">
-              <a:spcBef>
-                <a:spcPts val="800"/>
-              </a:spcBef>
-              <a:spcAft>
-                <a:spcPts val="0"/>
-              </a:spcAft>
-              <a:buNone/>
-            </a:pPr>
-            <a:r>
-              <a:rPr lang="en-US" sz="1600">
-                <a:solidFill>
-                  <a:schemeClr val="dk1"/>
-                </a:solidFill>
-                <a:latin typeface="Calibri"/>
-                <a:ea typeface="Calibri"/>
-                <a:cs typeface="Calibri"/>
-                <a:sym typeface="Calibri"/>
-              </a:rPr>
-              <a:t>Dataset: BooksCorpus (800M palabras) + Wikipedia inglesa (2,500M palabras)</a:t>
+              <a:t>4. Learning rate bajo (2e-5) para no 'destruir' el pre-training</a:t>
             </a:r>
             <a:endParaRPr/>
           </a:p>
@@ -17005,12 +17334,12 @@
 </p:sld>
 </file>
 
-<file path=ppt/slides/slide14.xml><?xml version="1.0" encoding="utf-8"?>
-<p:sld xmlns:a="http://schemas.openxmlformats.org/drawingml/2006/main" xmlns:r="http://schemas.openxmlformats.org/officeDocument/2006/relationships" xmlns:mc="http://schemas.openxmlformats.org/markup-compatibility/2006" xmlns:mv="urn:schemas-microsoft-com:mac:vml" xmlns:p="http://schemas.openxmlformats.org/presentationml/2006/main" xmlns:c="http://schemas.openxmlformats.org/drawingml/2006/chart" xmlns:dgm="http://schemas.openxmlformats.org/drawingml/2006/diagram" xmlns:o="urn:schemas-microsoft-com:office:office" xmlns:v="urn:schemas-microsoft-com:vml" xmlns:pvml="urn:schemas-microsoft-com:office:powerpoint" xmlns:com="http://schemas.openxmlformats.org/drawingml/2006/compatibility" xmlns:p14="http://schemas.microsoft.com/office/powerpoint/2010/main" xmlns:p15="http://schemas.microsoft.com/office/powerpoint/2012/main" xmlns:ahyp="http://schemas.microsoft.com/office/drawing/2018/hyperlinkcolor">
+<file path=ppt/slides/slide15.xml><?xml version="1.0" encoding="utf-8"?>
+<p:sld xmlns:a="http://schemas.openxmlformats.org/drawingml/2006/main" xmlns:r="http://schemas.openxmlformats.org/officeDocument/2006/relationships" xmlns:mc="http://schemas.openxmlformats.org/markup-compatibility/2006" xmlns:mv="urn:schemas-microsoft-com:mac:vml" xmlns:p="http://schemas.openxmlformats.org/presentationml/2006/main" xmlns:c="http://schemas.openxmlformats.org/drawingml/2006/chart" xmlns:dgm="http://schemas.openxmlformats.org/drawingml/2006/diagram" xmlns:o="urn:schemas-microsoft-com:office:office" xmlns:v="urn:schemas-microsoft-com:vml" xmlns:pvml="urn:schemas-microsoft-com:office:powerpoint" xmlns:com="http://schemas.openxmlformats.org/drawingml/2006/compatibility" xmlns:p14="http://schemas.microsoft.com/office/powerpoint/2010/main" xmlns:p15="http://schemas.microsoft.com/office/powerpoint/2012/main" xmlns:ahyp="http://schemas.microsoft.com/office/drawing/2018/hyperlinkcolor" show="0">
   <p:cSld>
     <p:spTree>
       <p:nvGrpSpPr>
-        <p:cNvPr id="165" name="Shape 165"/>
+        <p:cNvPr id="173" name="Shape 173"/>
         <p:cNvGrpSpPr/>
         <p:nvPr/>
       </p:nvGrpSpPr>
@@ -17024,7 +17353,560 @@
       </p:grpSpPr>
       <p:sp>
         <p:nvSpPr>
-          <p:cNvPr id="166" name="Google Shape;166;p13"/>
+          <p:cNvPr id="174" name="Google Shape;174;p14"/>
+          <p:cNvSpPr txBox="1"/>
+          <p:nvPr/>
+        </p:nvSpPr>
+        <p:spPr>
+          <a:xfrm>
+            <a:off x="457200" y="274320"/>
+            <a:ext cx="8229600" cy="731400"/>
+          </a:xfrm>
+          <a:prstGeom prst="rect">
+            <a:avLst/>
+          </a:prstGeom>
+          <a:noFill/>
+          <a:ln>
+            <a:noFill/>
+          </a:ln>
+        </p:spPr>
+        <p:txBody>
+          <a:bodyPr anchorCtr="0" anchor="t" bIns="45700" lIns="91425" spcFirstLastPara="1" rIns="91425" wrap="square" tIns="45700">
+            <a:spAutoFit/>
+          </a:bodyPr>
+          <a:lstStyle/>
+          <a:p>
+            <a:pPr indent="0" lvl="0" marL="0" marR="0" rtl="0" algn="l">
+              <a:spcBef>
+                <a:spcPts val="0"/>
+              </a:spcBef>
+              <a:spcAft>
+                <a:spcPts val="0"/>
+              </a:spcAft>
+              <a:buNone/>
+            </a:pPr>
+            <a:r>
+              <a:rPr b="1" lang="en-US" sz="2800">
+                <a:solidFill>
+                  <a:srgbClr val="003366"/>
+                </a:solidFill>
+                <a:latin typeface="Calibri"/>
+                <a:ea typeface="Calibri"/>
+                <a:cs typeface="Calibri"/>
+                <a:sym typeface="Calibri"/>
+              </a:rPr>
+              <a:t>¿Por qué BERT y no otros modelos?</a:t>
+            </a:r>
+            <a:endParaRPr/>
+          </a:p>
+        </p:txBody>
+      </p:sp>
+      <p:sp>
+        <p:nvSpPr>
+          <p:cNvPr id="175" name="Google Shape;175;p14"/>
+          <p:cNvSpPr txBox="1"/>
+          <p:nvPr/>
+        </p:nvSpPr>
+        <p:spPr>
+          <a:xfrm>
+            <a:off x="457200" y="847375"/>
+            <a:ext cx="8229600" cy="6618600"/>
+          </a:xfrm>
+          <a:prstGeom prst="rect">
+            <a:avLst/>
+          </a:prstGeom>
+          <a:noFill/>
+          <a:ln>
+            <a:noFill/>
+          </a:ln>
+        </p:spPr>
+        <p:txBody>
+          <a:bodyPr anchorCtr="0" anchor="t" bIns="45700" lIns="91425" spcFirstLastPara="1" rIns="91425" wrap="square" tIns="45700">
+            <a:spAutoFit/>
+          </a:bodyPr>
+          <a:lstStyle/>
+          <a:p>
+            <a:pPr indent="0" lvl="0" marL="0" marR="0" rtl="0" algn="l">
+              <a:spcBef>
+                <a:spcPts val="0"/>
+              </a:spcBef>
+              <a:spcAft>
+                <a:spcPts val="0"/>
+              </a:spcAft>
+              <a:buNone/>
+            </a:pPr>
+            <a:r>
+              <a:rPr lang="en-US" sz="1600">
+                <a:solidFill>
+                  <a:schemeClr val="dk1"/>
+                </a:solidFill>
+                <a:latin typeface="Calibri"/>
+                <a:ea typeface="Calibri"/>
+                <a:cs typeface="Calibri"/>
+                <a:sym typeface="Calibri"/>
+              </a:rPr>
+              <a:t>COMPARACIÓN DE MODELOS:</a:t>
+            </a:r>
+            <a:endParaRPr/>
+          </a:p>
+          <a:p>
+            <a:pPr indent="0" lvl="0" marL="0" marR="0" rtl="0" algn="l">
+              <a:spcBef>
+                <a:spcPts val="800"/>
+              </a:spcBef>
+              <a:spcAft>
+                <a:spcPts val="0"/>
+              </a:spcAft>
+              <a:buNone/>
+            </a:pPr>
+            <a:r>
+              <a:t/>
+            </a:r>
+            <a:endParaRPr sz="1600">
+              <a:solidFill>
+                <a:schemeClr val="dk1"/>
+              </a:solidFill>
+              <a:latin typeface="Calibri"/>
+              <a:ea typeface="Calibri"/>
+              <a:cs typeface="Calibri"/>
+              <a:sym typeface="Calibri"/>
+            </a:endParaRPr>
+          </a:p>
+          <a:p>
+            <a:pPr indent="0" lvl="0" marL="0" marR="0" rtl="0" algn="l">
+              <a:spcBef>
+                <a:spcPts val="800"/>
+              </a:spcBef>
+              <a:spcAft>
+                <a:spcPts val="0"/>
+              </a:spcAft>
+              <a:buNone/>
+            </a:pPr>
+            <a:r>
+              <a:rPr lang="en-US" sz="1600">
+                <a:solidFill>
+                  <a:schemeClr val="dk1"/>
+                </a:solidFill>
+                <a:latin typeface="Calibri"/>
+                <a:ea typeface="Calibri"/>
+                <a:cs typeface="Calibri"/>
+                <a:sym typeface="Calibri"/>
+              </a:rPr>
+              <a:t>Word2Vec / GloVe:</a:t>
+            </a:r>
+            <a:endParaRPr/>
+          </a:p>
+          <a:p>
+            <a:pPr indent="0" lvl="0" marL="0" marR="0" rtl="0" algn="l">
+              <a:spcBef>
+                <a:spcPts val="800"/>
+              </a:spcBef>
+              <a:spcAft>
+                <a:spcPts val="0"/>
+              </a:spcAft>
+              <a:buNone/>
+            </a:pPr>
+            <a:r>
+              <a:rPr lang="en-US" sz="1600">
+                <a:solidFill>
+                  <a:schemeClr val="dk1"/>
+                </a:solidFill>
+                <a:latin typeface="Calibri"/>
+                <a:ea typeface="Calibri"/>
+                <a:cs typeface="Calibri"/>
+                <a:sym typeface="Calibri"/>
+              </a:rPr>
+              <a:t>  ✗ Embeddings estáticos (misma representación siempre)</a:t>
+            </a:r>
+            <a:endParaRPr/>
+          </a:p>
+          <a:p>
+            <a:pPr indent="0" lvl="0" marL="0" marR="0" rtl="0" algn="l">
+              <a:spcBef>
+                <a:spcPts val="800"/>
+              </a:spcBef>
+              <a:spcAft>
+                <a:spcPts val="0"/>
+              </a:spcAft>
+              <a:buNone/>
+            </a:pPr>
+            <a:r>
+              <a:rPr lang="en-US" sz="1600">
+                <a:solidFill>
+                  <a:schemeClr val="dk1"/>
+                </a:solidFill>
+                <a:latin typeface="Calibri"/>
+                <a:ea typeface="Calibri"/>
+                <a:cs typeface="Calibri"/>
+                <a:sym typeface="Calibri"/>
+              </a:rPr>
+              <a:t>  ✓ Rápidos y buenos para ciertas tareas</a:t>
+            </a:r>
+            <a:endParaRPr/>
+          </a:p>
+          <a:p>
+            <a:pPr indent="0" lvl="0" marL="0" marR="0" rtl="0" algn="l">
+              <a:spcBef>
+                <a:spcPts val="800"/>
+              </a:spcBef>
+              <a:spcAft>
+                <a:spcPts val="0"/>
+              </a:spcAft>
+              <a:buNone/>
+            </a:pPr>
+            <a:r>
+              <a:t/>
+            </a:r>
+            <a:endParaRPr sz="1600">
+              <a:solidFill>
+                <a:schemeClr val="dk1"/>
+              </a:solidFill>
+              <a:latin typeface="Calibri"/>
+              <a:ea typeface="Calibri"/>
+              <a:cs typeface="Calibri"/>
+              <a:sym typeface="Calibri"/>
+            </a:endParaRPr>
+          </a:p>
+          <a:p>
+            <a:pPr indent="0" lvl="0" marL="0" marR="0" rtl="0" algn="l">
+              <a:spcBef>
+                <a:spcPts val="800"/>
+              </a:spcBef>
+              <a:spcAft>
+                <a:spcPts val="0"/>
+              </a:spcAft>
+              <a:buNone/>
+            </a:pPr>
+            <a:r>
+              <a:rPr lang="en-US" sz="1600">
+                <a:solidFill>
+                  <a:schemeClr val="dk1"/>
+                </a:solidFill>
+                <a:latin typeface="Calibri"/>
+                <a:ea typeface="Calibri"/>
+                <a:cs typeface="Calibri"/>
+                <a:sym typeface="Calibri"/>
+              </a:rPr>
+              <a:t>ELMo (2018):</a:t>
+            </a:r>
+            <a:endParaRPr/>
+          </a:p>
+          <a:p>
+            <a:pPr indent="0" lvl="0" marL="0" marR="0" rtl="0" algn="l">
+              <a:spcBef>
+                <a:spcPts val="800"/>
+              </a:spcBef>
+              <a:spcAft>
+                <a:spcPts val="0"/>
+              </a:spcAft>
+              <a:buNone/>
+            </a:pPr>
+            <a:r>
+              <a:rPr lang="en-US" sz="1600">
+                <a:solidFill>
+                  <a:schemeClr val="dk1"/>
+                </a:solidFill>
+                <a:latin typeface="Calibri"/>
+                <a:ea typeface="Calibri"/>
+                <a:cs typeface="Calibri"/>
+                <a:sym typeface="Calibri"/>
+              </a:rPr>
+              <a:t>  ✓ Embeddings contextuales (LSTM bidireccional)</a:t>
+            </a:r>
+            <a:endParaRPr/>
+          </a:p>
+          <a:p>
+            <a:pPr indent="0" lvl="0" marL="0" marR="0" rtl="0" algn="l">
+              <a:spcBef>
+                <a:spcPts val="800"/>
+              </a:spcBef>
+              <a:spcAft>
+                <a:spcPts val="0"/>
+              </a:spcAft>
+              <a:buNone/>
+            </a:pPr>
+            <a:r>
+              <a:rPr lang="en-US" sz="1600">
+                <a:solidFill>
+                  <a:schemeClr val="dk1"/>
+                </a:solidFill>
+                <a:latin typeface="Calibri"/>
+                <a:ea typeface="Calibri"/>
+                <a:cs typeface="Calibri"/>
+                <a:sym typeface="Calibri"/>
+              </a:rPr>
+              <a:t>  ✗ Más lento que Transformers, menor capacidad</a:t>
+            </a:r>
+            <a:endParaRPr/>
+          </a:p>
+          <a:p>
+            <a:pPr indent="0" lvl="0" marL="0" marR="0" rtl="0" algn="l">
+              <a:spcBef>
+                <a:spcPts val="800"/>
+              </a:spcBef>
+              <a:spcAft>
+                <a:spcPts val="0"/>
+              </a:spcAft>
+              <a:buNone/>
+            </a:pPr>
+            <a:r>
+              <a:t/>
+            </a:r>
+            <a:endParaRPr sz="1600">
+              <a:solidFill>
+                <a:schemeClr val="dk1"/>
+              </a:solidFill>
+              <a:latin typeface="Calibri"/>
+              <a:ea typeface="Calibri"/>
+              <a:cs typeface="Calibri"/>
+              <a:sym typeface="Calibri"/>
+            </a:endParaRPr>
+          </a:p>
+          <a:p>
+            <a:pPr indent="0" lvl="0" marL="0" marR="0" rtl="0" algn="l">
+              <a:spcBef>
+                <a:spcPts val="800"/>
+              </a:spcBef>
+              <a:spcAft>
+                <a:spcPts val="0"/>
+              </a:spcAft>
+              <a:buNone/>
+            </a:pPr>
+            <a:r>
+              <a:rPr lang="en-US" sz="1600">
+                <a:solidFill>
+                  <a:schemeClr val="dk1"/>
+                </a:solidFill>
+                <a:latin typeface="Calibri"/>
+                <a:ea typeface="Calibri"/>
+                <a:cs typeface="Calibri"/>
+                <a:sym typeface="Calibri"/>
+              </a:rPr>
+              <a:t>GPT (decoder-only):</a:t>
+            </a:r>
+            <a:endParaRPr/>
+          </a:p>
+          <a:p>
+            <a:pPr indent="0" lvl="0" marL="0" marR="0" rtl="0" algn="l">
+              <a:spcBef>
+                <a:spcPts val="800"/>
+              </a:spcBef>
+              <a:spcAft>
+                <a:spcPts val="0"/>
+              </a:spcAft>
+              <a:buNone/>
+            </a:pPr>
+            <a:r>
+              <a:rPr lang="en-US" sz="1600">
+                <a:solidFill>
+                  <a:schemeClr val="dk1"/>
+                </a:solidFill>
+                <a:latin typeface="Calibri"/>
+                <a:ea typeface="Calibri"/>
+                <a:cs typeface="Calibri"/>
+                <a:sym typeface="Calibri"/>
+              </a:rPr>
+              <a:t>  ✗ Unidireccional (solo contexto previo)</a:t>
+            </a:r>
+            <a:endParaRPr/>
+          </a:p>
+          <a:p>
+            <a:pPr indent="0" lvl="0" marL="0" marR="0" rtl="0" algn="l">
+              <a:spcBef>
+                <a:spcPts val="800"/>
+              </a:spcBef>
+              <a:spcAft>
+                <a:spcPts val="0"/>
+              </a:spcAft>
+              <a:buNone/>
+            </a:pPr>
+            <a:r>
+              <a:rPr lang="en-US" sz="1600">
+                <a:solidFill>
+                  <a:schemeClr val="dk1"/>
+                </a:solidFill>
+                <a:latin typeface="Calibri"/>
+                <a:ea typeface="Calibri"/>
+                <a:cs typeface="Calibri"/>
+                <a:sym typeface="Calibri"/>
+              </a:rPr>
+              <a:t>  ✓ Excelente para generación de texto</a:t>
+            </a:r>
+            <a:endParaRPr/>
+          </a:p>
+          <a:p>
+            <a:pPr indent="0" lvl="0" marL="0" marR="0" rtl="0" algn="l">
+              <a:spcBef>
+                <a:spcPts val="800"/>
+              </a:spcBef>
+              <a:spcAft>
+                <a:spcPts val="0"/>
+              </a:spcAft>
+              <a:buNone/>
+            </a:pPr>
+            <a:r>
+              <a:t/>
+            </a:r>
+            <a:endParaRPr sz="1600">
+              <a:solidFill>
+                <a:schemeClr val="dk1"/>
+              </a:solidFill>
+              <a:latin typeface="Calibri"/>
+              <a:ea typeface="Calibri"/>
+              <a:cs typeface="Calibri"/>
+              <a:sym typeface="Calibri"/>
+            </a:endParaRPr>
+          </a:p>
+          <a:p>
+            <a:pPr indent="0" lvl="0" marL="0" marR="0" rtl="0" algn="l">
+              <a:spcBef>
+                <a:spcPts val="800"/>
+              </a:spcBef>
+              <a:spcAft>
+                <a:spcPts val="0"/>
+              </a:spcAft>
+              <a:buNone/>
+            </a:pPr>
+            <a:r>
+              <a:rPr lang="en-US" sz="1600">
+                <a:solidFill>
+                  <a:schemeClr val="dk1"/>
+                </a:solidFill>
+                <a:latin typeface="Calibri"/>
+                <a:ea typeface="Calibri"/>
+                <a:cs typeface="Calibri"/>
+                <a:sym typeface="Calibri"/>
+              </a:rPr>
+              <a:t>BERT (encoder-only):</a:t>
+            </a:r>
+            <a:endParaRPr/>
+          </a:p>
+          <a:p>
+            <a:pPr indent="0" lvl="0" marL="0" marR="0" rtl="0" algn="l">
+              <a:spcBef>
+                <a:spcPts val="800"/>
+              </a:spcBef>
+              <a:spcAft>
+                <a:spcPts val="0"/>
+              </a:spcAft>
+              <a:buNone/>
+            </a:pPr>
+            <a:r>
+              <a:rPr lang="en-US" sz="1600">
+                <a:solidFill>
+                  <a:schemeClr val="dk1"/>
+                </a:solidFill>
+                <a:latin typeface="Calibri"/>
+                <a:ea typeface="Calibri"/>
+                <a:cs typeface="Calibri"/>
+                <a:sym typeface="Calibri"/>
+              </a:rPr>
+              <a:t>  ✓ Bidireccional: contexto completo (izquierda + derecha)</a:t>
+            </a:r>
+            <a:endParaRPr/>
+          </a:p>
+          <a:p>
+            <a:pPr indent="0" lvl="0" marL="0" marR="0" rtl="0" algn="l">
+              <a:spcBef>
+                <a:spcPts val="800"/>
+              </a:spcBef>
+              <a:spcAft>
+                <a:spcPts val="0"/>
+              </a:spcAft>
+              <a:buNone/>
+            </a:pPr>
+            <a:r>
+              <a:rPr lang="en-US" sz="1600">
+                <a:solidFill>
+                  <a:schemeClr val="dk1"/>
+                </a:solidFill>
+                <a:latin typeface="Calibri"/>
+                <a:ea typeface="Calibri"/>
+                <a:cs typeface="Calibri"/>
+                <a:sym typeface="Calibri"/>
+              </a:rPr>
+              <a:t>  ✓ State-of-the-art en clasificación (2018-2020)</a:t>
+            </a:r>
+            <a:endParaRPr/>
+          </a:p>
+          <a:p>
+            <a:pPr indent="0" lvl="0" marL="0" marR="0" rtl="0" algn="l">
+              <a:spcBef>
+                <a:spcPts val="800"/>
+              </a:spcBef>
+              <a:spcAft>
+                <a:spcPts val="0"/>
+              </a:spcAft>
+              <a:buNone/>
+            </a:pPr>
+            <a:r>
+              <a:rPr lang="en-US" sz="1600">
+                <a:solidFill>
+                  <a:schemeClr val="dk1"/>
+                </a:solidFill>
+                <a:latin typeface="Calibri"/>
+                <a:ea typeface="Calibri"/>
+                <a:cs typeface="Calibri"/>
+                <a:sym typeface="Calibri"/>
+              </a:rPr>
+              <a:t>  ✓ Modelo pre-entrenado disponible en Hugging Face</a:t>
+            </a:r>
+            <a:endParaRPr/>
+          </a:p>
+          <a:p>
+            <a:pPr indent="0" lvl="0" marL="0" marR="0" rtl="0" algn="l">
+              <a:spcBef>
+                <a:spcPts val="800"/>
+              </a:spcBef>
+              <a:spcAft>
+                <a:spcPts val="0"/>
+              </a:spcAft>
+              <a:buNone/>
+            </a:pPr>
+            <a:r>
+              <a:rPr lang="en-US" sz="1600">
+                <a:solidFill>
+                  <a:schemeClr val="dk1"/>
+                </a:solidFill>
+                <a:latin typeface="Calibri"/>
+                <a:ea typeface="Calibri"/>
+                <a:cs typeface="Calibri"/>
+                <a:sym typeface="Calibri"/>
+              </a:rPr>
+              <a:t>  ✓ Documentación extensa y comunidad activa</a:t>
+            </a:r>
+            <a:endParaRPr/>
+          </a:p>
+        </p:txBody>
+      </p:sp>
+    </p:spTree>
+  </p:cSld>
+  <p:clrMapOvr>
+    <a:masterClrMapping/>
+  </p:clrMapOvr>
+</p:sld>
+</file>
+
+<file path=ppt/slides/slide16.xml><?xml version="1.0" encoding="utf-8"?>
+<p:sld xmlns:a="http://schemas.openxmlformats.org/drawingml/2006/main" xmlns:r="http://schemas.openxmlformats.org/officeDocument/2006/relationships" xmlns:mc="http://schemas.openxmlformats.org/markup-compatibility/2006" xmlns:mv="urn:schemas-microsoft-com:mac:vml" xmlns:p="http://schemas.openxmlformats.org/presentationml/2006/main" xmlns:c="http://schemas.openxmlformats.org/drawingml/2006/chart" xmlns:dgm="http://schemas.openxmlformats.org/drawingml/2006/diagram" xmlns:o="urn:schemas-microsoft-com:office:office" xmlns:v="urn:schemas-microsoft-com:vml" xmlns:pvml="urn:schemas-microsoft-com:office:powerpoint" xmlns:com="http://schemas.openxmlformats.org/drawingml/2006/compatibility" xmlns:p14="http://schemas.microsoft.com/office/powerpoint/2010/main" xmlns:p15="http://schemas.microsoft.com/office/powerpoint/2012/main" xmlns:ahyp="http://schemas.microsoft.com/office/drawing/2018/hyperlinkcolor">
+  <p:cSld>
+    <p:spTree>
+      <p:nvGrpSpPr>
+        <p:cNvPr id="179" name="Shape 179"/>
+        <p:cNvGrpSpPr/>
+        <p:nvPr/>
+      </p:nvGrpSpPr>
+      <p:grpSpPr>
+        <a:xfrm>
+          <a:off x="0" y="0"/>
+          <a:ext cx="0" cy="0"/>
+          <a:chOff x="0" y="0"/>
+          <a:chExt cx="0" cy="0"/>
+        </a:xfrm>
+      </p:grpSpPr>
+      <p:sp>
+        <p:nvSpPr>
+          <p:cNvPr id="180" name="Google Shape;180;p15"/>
           <p:cNvSpPr txBox="1"/>
           <p:nvPr/>
         </p:nvSpPr>
@@ -17066,7 +17948,7 @@
                 <a:cs typeface="Calibri"/>
                 <a:sym typeface="Calibri"/>
               </a:rPr>
-              <a:t>Fine-Tuning de BERT</a:t>
+              <a:t>Tokenización con BERT</a:t>
             </a:r>
             <a:endParaRPr/>
           </a:p>
@@ -17074,924 +17956,7 @@
       </p:sp>
       <p:sp>
         <p:nvSpPr>
-          <p:cNvPr id="167" name="Google Shape;167;p13"/>
-          <p:cNvSpPr txBox="1"/>
-          <p:nvPr/>
-        </p:nvSpPr>
-        <p:spPr>
-          <a:xfrm>
-            <a:off x="418450" y="956220"/>
-            <a:ext cx="8229600" cy="3827400"/>
-          </a:xfrm>
-          <a:prstGeom prst="rect">
-            <a:avLst/>
-          </a:prstGeom>
-          <a:noFill/>
-          <a:ln>
-            <a:noFill/>
-          </a:ln>
-        </p:spPr>
-        <p:txBody>
-          <a:bodyPr anchorCtr="0" anchor="t" bIns="45700" lIns="91425" spcFirstLastPara="1" rIns="91425" wrap="square" tIns="45700">
-            <a:spAutoFit/>
-          </a:bodyPr>
-          <a:lstStyle/>
-          <a:p>
-            <a:pPr indent="0" lvl="0" marL="0" marR="0" rtl="0" algn="l">
-              <a:spcBef>
-                <a:spcPts val="800"/>
-              </a:spcBef>
-              <a:spcAft>
-                <a:spcPts val="0"/>
-              </a:spcAft>
-              <a:buNone/>
-            </a:pPr>
-            <a:r>
-              <a:rPr lang="en-US" sz="1600">
-                <a:solidFill>
-                  <a:schemeClr val="dk1"/>
-                </a:solidFill>
-                <a:latin typeface="Calibri"/>
-                <a:ea typeface="Calibri"/>
-                <a:cs typeface="Calibri"/>
-                <a:sym typeface="Calibri"/>
-              </a:rPr>
-              <a:t>VENTAJAS DE TRANSFER LEARNING:</a:t>
-            </a:r>
-            <a:endParaRPr/>
-          </a:p>
-          <a:p>
-            <a:pPr indent="0" lvl="0" marL="0" marR="0" rtl="0" algn="l">
-              <a:spcBef>
-                <a:spcPts val="800"/>
-              </a:spcBef>
-              <a:spcAft>
-                <a:spcPts val="0"/>
-              </a:spcAft>
-              <a:buNone/>
-            </a:pPr>
-            <a:r>
-              <a:rPr lang="en-US" sz="1600">
-                <a:solidFill>
-                  <a:schemeClr val="dk1"/>
-                </a:solidFill>
-                <a:latin typeface="Calibri"/>
-                <a:ea typeface="Calibri"/>
-                <a:cs typeface="Calibri"/>
-                <a:sym typeface="Calibri"/>
-              </a:rPr>
-              <a:t>• Aprovecha conocimiento lingüístico general del pre-training</a:t>
-            </a:r>
-            <a:endParaRPr/>
-          </a:p>
-          <a:p>
-            <a:pPr indent="0" lvl="0" marL="0" marR="0" rtl="0" algn="l">
-              <a:spcBef>
-                <a:spcPts val="800"/>
-              </a:spcBef>
-              <a:spcAft>
-                <a:spcPts val="0"/>
-              </a:spcAft>
-              <a:buNone/>
-            </a:pPr>
-            <a:r>
-              <a:rPr lang="en-US" sz="1600">
-                <a:solidFill>
-                  <a:schemeClr val="dk1"/>
-                </a:solidFill>
-                <a:latin typeface="Calibri"/>
-                <a:ea typeface="Calibri"/>
-                <a:cs typeface="Calibri"/>
-                <a:sym typeface="Calibri"/>
-              </a:rPr>
-              <a:t>• Requiere menos datos etiquetados que entrenar from scratch</a:t>
-            </a:r>
-            <a:endParaRPr/>
-          </a:p>
-          <a:p>
-            <a:pPr indent="0" lvl="0" marL="0" marR="0" rtl="0" algn="l">
-              <a:spcBef>
-                <a:spcPts val="800"/>
-              </a:spcBef>
-              <a:spcAft>
-                <a:spcPts val="0"/>
-              </a:spcAft>
-              <a:buNone/>
-            </a:pPr>
-            <a:r>
-              <a:rPr lang="en-US" sz="1600">
-                <a:solidFill>
-                  <a:schemeClr val="dk1"/>
-                </a:solidFill>
-                <a:latin typeface="Calibri"/>
-                <a:ea typeface="Calibri"/>
-                <a:cs typeface="Calibri"/>
-                <a:sym typeface="Calibri"/>
-              </a:rPr>
-              <a:t>• Mejor performance y convergencia más rápida</a:t>
-            </a:r>
-            <a:endParaRPr/>
-          </a:p>
-          <a:p>
-            <a:pPr indent="0" lvl="0" marL="0" marR="0" rtl="0" algn="l">
-              <a:spcBef>
-                <a:spcPts val="800"/>
-              </a:spcBef>
-              <a:spcAft>
-                <a:spcPts val="0"/>
-              </a:spcAft>
-              <a:buNone/>
-            </a:pPr>
-            <a:r>
-              <a:rPr lang="en-US" sz="1600">
-                <a:solidFill>
-                  <a:schemeClr val="dk1"/>
-                </a:solidFill>
-                <a:latin typeface="Calibri"/>
-                <a:ea typeface="Calibri"/>
-                <a:cs typeface="Calibri"/>
-                <a:sym typeface="Calibri"/>
-              </a:rPr>
-              <a:t>• Generaliza mejor en dominios específicos</a:t>
-            </a:r>
-            <a:endParaRPr/>
-          </a:p>
-          <a:p>
-            <a:pPr indent="0" lvl="0" marL="0" marR="0" rtl="0" algn="l">
-              <a:spcBef>
-                <a:spcPts val="800"/>
-              </a:spcBef>
-              <a:spcAft>
-                <a:spcPts val="0"/>
-              </a:spcAft>
-              <a:buNone/>
-            </a:pPr>
-            <a:r>
-              <a:t/>
-            </a:r>
-            <a:endParaRPr sz="1600">
-              <a:solidFill>
-                <a:schemeClr val="dk1"/>
-              </a:solidFill>
-              <a:latin typeface="Calibri"/>
-              <a:ea typeface="Calibri"/>
-              <a:cs typeface="Calibri"/>
-              <a:sym typeface="Calibri"/>
-            </a:endParaRPr>
-          </a:p>
-          <a:p>
-            <a:pPr indent="0" lvl="0" marL="0" marR="0" rtl="0" algn="l">
-              <a:spcBef>
-                <a:spcPts val="800"/>
-              </a:spcBef>
-              <a:spcAft>
-                <a:spcPts val="0"/>
-              </a:spcAft>
-              <a:buNone/>
-            </a:pPr>
-            <a:r>
-              <a:rPr lang="en-US" sz="1600">
-                <a:solidFill>
-                  <a:schemeClr val="dk1"/>
-                </a:solidFill>
-                <a:latin typeface="Calibri"/>
-                <a:ea typeface="Calibri"/>
-                <a:cs typeface="Calibri"/>
-                <a:sym typeface="Calibri"/>
-              </a:rPr>
-              <a:t>PROCESO:</a:t>
-            </a:r>
-            <a:endParaRPr/>
-          </a:p>
-          <a:p>
-            <a:pPr indent="0" lvl="0" marL="0" marR="0" rtl="0" algn="l">
-              <a:spcBef>
-                <a:spcPts val="800"/>
-              </a:spcBef>
-              <a:spcAft>
-                <a:spcPts val="0"/>
-              </a:spcAft>
-              <a:buNone/>
-            </a:pPr>
-            <a:r>
-              <a:rPr lang="en-US" sz="1600">
-                <a:solidFill>
-                  <a:schemeClr val="dk1"/>
-                </a:solidFill>
-                <a:latin typeface="Calibri"/>
-                <a:ea typeface="Calibri"/>
-                <a:cs typeface="Calibri"/>
-                <a:sym typeface="Calibri"/>
-              </a:rPr>
-              <a:t>1. Cargar BERT pre-entrenado (pesos de MLM + NSP)</a:t>
-            </a:r>
-            <a:endParaRPr/>
-          </a:p>
-          <a:p>
-            <a:pPr indent="0" lvl="0" marL="0" marR="0" rtl="0" algn="l">
-              <a:spcBef>
-                <a:spcPts val="800"/>
-              </a:spcBef>
-              <a:spcAft>
-                <a:spcPts val="0"/>
-              </a:spcAft>
-              <a:buNone/>
-            </a:pPr>
-            <a:r>
-              <a:rPr lang="en-US" sz="1600">
-                <a:solidFill>
-                  <a:schemeClr val="dk1"/>
-                </a:solidFill>
-                <a:latin typeface="Calibri"/>
-                <a:ea typeface="Calibri"/>
-                <a:cs typeface="Calibri"/>
-                <a:sym typeface="Calibri"/>
-              </a:rPr>
-              <a:t>2. Agregar capa de clasificación task-specific (linear layer)</a:t>
-            </a:r>
-            <a:endParaRPr/>
-          </a:p>
-          <a:p>
-            <a:pPr indent="0" lvl="0" marL="0" marR="0" rtl="0" algn="l">
-              <a:spcBef>
-                <a:spcPts val="800"/>
-              </a:spcBef>
-              <a:spcAft>
-                <a:spcPts val="0"/>
-              </a:spcAft>
-              <a:buNone/>
-            </a:pPr>
-            <a:r>
-              <a:rPr lang="en-US" sz="1600">
-                <a:solidFill>
-                  <a:schemeClr val="dk1"/>
-                </a:solidFill>
-                <a:latin typeface="Calibri"/>
-                <a:ea typeface="Calibri"/>
-                <a:cs typeface="Calibri"/>
-                <a:sym typeface="Calibri"/>
-              </a:rPr>
-              <a:t>3. Fine-tunear TODAS las capas (no solo la capa final)</a:t>
-            </a:r>
-            <a:endParaRPr/>
-          </a:p>
-          <a:p>
-            <a:pPr indent="0" lvl="0" marL="0" marR="0" rtl="0" algn="l">
-              <a:spcBef>
-                <a:spcPts val="800"/>
-              </a:spcBef>
-              <a:spcAft>
-                <a:spcPts val="0"/>
-              </a:spcAft>
-              <a:buNone/>
-            </a:pPr>
-            <a:r>
-              <a:rPr lang="en-US" sz="1600">
-                <a:solidFill>
-                  <a:schemeClr val="dk1"/>
-                </a:solidFill>
-                <a:latin typeface="Calibri"/>
-                <a:ea typeface="Calibri"/>
-                <a:cs typeface="Calibri"/>
-                <a:sym typeface="Calibri"/>
-              </a:rPr>
-              <a:t>4. Learning rate bajo (2e-5) para no 'destruir' el pre-training</a:t>
-            </a:r>
-            <a:endParaRPr/>
-          </a:p>
-        </p:txBody>
-      </p:sp>
-    </p:spTree>
-  </p:cSld>
-  <p:clrMapOvr>
-    <a:masterClrMapping/>
-  </p:clrMapOvr>
-</p:sld>
-</file>
-
-<file path=ppt/slides/slide15.xml><?xml version="1.0" encoding="utf-8"?>
-<p:sld xmlns:a="http://schemas.openxmlformats.org/drawingml/2006/main" xmlns:r="http://schemas.openxmlformats.org/officeDocument/2006/relationships" xmlns:mc="http://schemas.openxmlformats.org/markup-compatibility/2006" xmlns:mv="urn:schemas-microsoft-com:mac:vml" xmlns:p="http://schemas.openxmlformats.org/presentationml/2006/main" xmlns:c="http://schemas.openxmlformats.org/drawingml/2006/chart" xmlns:dgm="http://schemas.openxmlformats.org/drawingml/2006/diagram" xmlns:o="urn:schemas-microsoft-com:office:office" xmlns:v="urn:schemas-microsoft-com:vml" xmlns:pvml="urn:schemas-microsoft-com:office:powerpoint" xmlns:com="http://schemas.openxmlformats.org/drawingml/2006/compatibility" xmlns:p14="http://schemas.microsoft.com/office/powerpoint/2010/main" xmlns:p15="http://schemas.microsoft.com/office/powerpoint/2012/main" xmlns:ahyp="http://schemas.microsoft.com/office/drawing/2018/hyperlinkcolor" show="0">
-  <p:cSld>
-    <p:spTree>
-      <p:nvGrpSpPr>
-        <p:cNvPr id="171" name="Shape 171"/>
-        <p:cNvGrpSpPr/>
-        <p:nvPr/>
-      </p:nvGrpSpPr>
-      <p:grpSpPr>
-        <a:xfrm>
-          <a:off x="0" y="0"/>
-          <a:ext cx="0" cy="0"/>
-          <a:chOff x="0" y="0"/>
-          <a:chExt cx="0" cy="0"/>
-        </a:xfrm>
-      </p:grpSpPr>
-      <p:sp>
-        <p:nvSpPr>
-          <p:cNvPr id="172" name="Google Shape;172;p14"/>
-          <p:cNvSpPr txBox="1"/>
-          <p:nvPr/>
-        </p:nvSpPr>
-        <p:spPr>
-          <a:xfrm>
-            <a:off x="457200" y="274320"/>
-            <a:ext cx="8229600" cy="731400"/>
-          </a:xfrm>
-          <a:prstGeom prst="rect">
-            <a:avLst/>
-          </a:prstGeom>
-          <a:noFill/>
-          <a:ln>
-            <a:noFill/>
-          </a:ln>
-        </p:spPr>
-        <p:txBody>
-          <a:bodyPr anchorCtr="0" anchor="t" bIns="45700" lIns="91425" spcFirstLastPara="1" rIns="91425" wrap="square" tIns="45700">
-            <a:spAutoFit/>
-          </a:bodyPr>
-          <a:lstStyle/>
-          <a:p>
-            <a:pPr indent="0" lvl="0" marL="0" marR="0" rtl="0" algn="l">
-              <a:spcBef>
-                <a:spcPts val="0"/>
-              </a:spcBef>
-              <a:spcAft>
-                <a:spcPts val="0"/>
-              </a:spcAft>
-              <a:buNone/>
-            </a:pPr>
-            <a:r>
-              <a:rPr b="1" lang="en-US" sz="2800">
-                <a:solidFill>
-                  <a:srgbClr val="003366"/>
-                </a:solidFill>
-                <a:latin typeface="Calibri"/>
-                <a:ea typeface="Calibri"/>
-                <a:cs typeface="Calibri"/>
-                <a:sym typeface="Calibri"/>
-              </a:rPr>
-              <a:t>¿Por qué BERT y no otros modelos?</a:t>
-            </a:r>
-            <a:endParaRPr/>
-          </a:p>
-        </p:txBody>
-      </p:sp>
-      <p:sp>
-        <p:nvSpPr>
-          <p:cNvPr id="173" name="Google Shape;173;p14"/>
-          <p:cNvSpPr txBox="1"/>
-          <p:nvPr/>
-        </p:nvSpPr>
-        <p:spPr>
-          <a:xfrm>
-            <a:off x="457200" y="847375"/>
-            <a:ext cx="8229600" cy="6618600"/>
-          </a:xfrm>
-          <a:prstGeom prst="rect">
-            <a:avLst/>
-          </a:prstGeom>
-          <a:noFill/>
-          <a:ln>
-            <a:noFill/>
-          </a:ln>
-        </p:spPr>
-        <p:txBody>
-          <a:bodyPr anchorCtr="0" anchor="t" bIns="45700" lIns="91425" spcFirstLastPara="1" rIns="91425" wrap="square" tIns="45700">
-            <a:spAutoFit/>
-          </a:bodyPr>
-          <a:lstStyle/>
-          <a:p>
-            <a:pPr indent="0" lvl="0" marL="0" marR="0" rtl="0" algn="l">
-              <a:spcBef>
-                <a:spcPts val="0"/>
-              </a:spcBef>
-              <a:spcAft>
-                <a:spcPts val="0"/>
-              </a:spcAft>
-              <a:buNone/>
-            </a:pPr>
-            <a:r>
-              <a:rPr lang="en-US" sz="1600">
-                <a:solidFill>
-                  <a:schemeClr val="dk1"/>
-                </a:solidFill>
-                <a:latin typeface="Calibri"/>
-                <a:ea typeface="Calibri"/>
-                <a:cs typeface="Calibri"/>
-                <a:sym typeface="Calibri"/>
-              </a:rPr>
-              <a:t>COMPARACIÓN DE MODELOS:</a:t>
-            </a:r>
-            <a:endParaRPr/>
-          </a:p>
-          <a:p>
-            <a:pPr indent="0" lvl="0" marL="0" marR="0" rtl="0" algn="l">
-              <a:spcBef>
-                <a:spcPts val="800"/>
-              </a:spcBef>
-              <a:spcAft>
-                <a:spcPts val="0"/>
-              </a:spcAft>
-              <a:buNone/>
-            </a:pPr>
-            <a:r>
-              <a:t/>
-            </a:r>
-            <a:endParaRPr sz="1600">
-              <a:solidFill>
-                <a:schemeClr val="dk1"/>
-              </a:solidFill>
-              <a:latin typeface="Calibri"/>
-              <a:ea typeface="Calibri"/>
-              <a:cs typeface="Calibri"/>
-              <a:sym typeface="Calibri"/>
-            </a:endParaRPr>
-          </a:p>
-          <a:p>
-            <a:pPr indent="0" lvl="0" marL="0" marR="0" rtl="0" algn="l">
-              <a:spcBef>
-                <a:spcPts val="800"/>
-              </a:spcBef>
-              <a:spcAft>
-                <a:spcPts val="0"/>
-              </a:spcAft>
-              <a:buNone/>
-            </a:pPr>
-            <a:r>
-              <a:rPr lang="en-US" sz="1600">
-                <a:solidFill>
-                  <a:schemeClr val="dk1"/>
-                </a:solidFill>
-                <a:latin typeface="Calibri"/>
-                <a:ea typeface="Calibri"/>
-                <a:cs typeface="Calibri"/>
-                <a:sym typeface="Calibri"/>
-              </a:rPr>
-              <a:t>Word2Vec / GloVe:</a:t>
-            </a:r>
-            <a:endParaRPr/>
-          </a:p>
-          <a:p>
-            <a:pPr indent="0" lvl="0" marL="0" marR="0" rtl="0" algn="l">
-              <a:spcBef>
-                <a:spcPts val="800"/>
-              </a:spcBef>
-              <a:spcAft>
-                <a:spcPts val="0"/>
-              </a:spcAft>
-              <a:buNone/>
-            </a:pPr>
-            <a:r>
-              <a:rPr lang="en-US" sz="1600">
-                <a:solidFill>
-                  <a:schemeClr val="dk1"/>
-                </a:solidFill>
-                <a:latin typeface="Calibri"/>
-                <a:ea typeface="Calibri"/>
-                <a:cs typeface="Calibri"/>
-                <a:sym typeface="Calibri"/>
-              </a:rPr>
-              <a:t>  ✗ Embeddings estáticos (misma representación siempre)</a:t>
-            </a:r>
-            <a:endParaRPr/>
-          </a:p>
-          <a:p>
-            <a:pPr indent="0" lvl="0" marL="0" marR="0" rtl="0" algn="l">
-              <a:spcBef>
-                <a:spcPts val="800"/>
-              </a:spcBef>
-              <a:spcAft>
-                <a:spcPts val="0"/>
-              </a:spcAft>
-              <a:buNone/>
-            </a:pPr>
-            <a:r>
-              <a:rPr lang="en-US" sz="1600">
-                <a:solidFill>
-                  <a:schemeClr val="dk1"/>
-                </a:solidFill>
-                <a:latin typeface="Calibri"/>
-                <a:ea typeface="Calibri"/>
-                <a:cs typeface="Calibri"/>
-                <a:sym typeface="Calibri"/>
-              </a:rPr>
-              <a:t>  ✓ Rápidos y buenos para ciertas tareas</a:t>
-            </a:r>
-            <a:endParaRPr/>
-          </a:p>
-          <a:p>
-            <a:pPr indent="0" lvl="0" marL="0" marR="0" rtl="0" algn="l">
-              <a:spcBef>
-                <a:spcPts val="800"/>
-              </a:spcBef>
-              <a:spcAft>
-                <a:spcPts val="0"/>
-              </a:spcAft>
-              <a:buNone/>
-            </a:pPr>
-            <a:r>
-              <a:t/>
-            </a:r>
-            <a:endParaRPr sz="1600">
-              <a:solidFill>
-                <a:schemeClr val="dk1"/>
-              </a:solidFill>
-              <a:latin typeface="Calibri"/>
-              <a:ea typeface="Calibri"/>
-              <a:cs typeface="Calibri"/>
-              <a:sym typeface="Calibri"/>
-            </a:endParaRPr>
-          </a:p>
-          <a:p>
-            <a:pPr indent="0" lvl="0" marL="0" marR="0" rtl="0" algn="l">
-              <a:spcBef>
-                <a:spcPts val="800"/>
-              </a:spcBef>
-              <a:spcAft>
-                <a:spcPts val="0"/>
-              </a:spcAft>
-              <a:buNone/>
-            </a:pPr>
-            <a:r>
-              <a:rPr lang="en-US" sz="1600">
-                <a:solidFill>
-                  <a:schemeClr val="dk1"/>
-                </a:solidFill>
-                <a:latin typeface="Calibri"/>
-                <a:ea typeface="Calibri"/>
-                <a:cs typeface="Calibri"/>
-                <a:sym typeface="Calibri"/>
-              </a:rPr>
-              <a:t>ELMo (2018):</a:t>
-            </a:r>
-            <a:endParaRPr/>
-          </a:p>
-          <a:p>
-            <a:pPr indent="0" lvl="0" marL="0" marR="0" rtl="0" algn="l">
-              <a:spcBef>
-                <a:spcPts val="800"/>
-              </a:spcBef>
-              <a:spcAft>
-                <a:spcPts val="0"/>
-              </a:spcAft>
-              <a:buNone/>
-            </a:pPr>
-            <a:r>
-              <a:rPr lang="en-US" sz="1600">
-                <a:solidFill>
-                  <a:schemeClr val="dk1"/>
-                </a:solidFill>
-                <a:latin typeface="Calibri"/>
-                <a:ea typeface="Calibri"/>
-                <a:cs typeface="Calibri"/>
-                <a:sym typeface="Calibri"/>
-              </a:rPr>
-              <a:t>  ✓ Embeddings contextuales (LSTM bidireccional)</a:t>
-            </a:r>
-            <a:endParaRPr/>
-          </a:p>
-          <a:p>
-            <a:pPr indent="0" lvl="0" marL="0" marR="0" rtl="0" algn="l">
-              <a:spcBef>
-                <a:spcPts val="800"/>
-              </a:spcBef>
-              <a:spcAft>
-                <a:spcPts val="0"/>
-              </a:spcAft>
-              <a:buNone/>
-            </a:pPr>
-            <a:r>
-              <a:rPr lang="en-US" sz="1600">
-                <a:solidFill>
-                  <a:schemeClr val="dk1"/>
-                </a:solidFill>
-                <a:latin typeface="Calibri"/>
-                <a:ea typeface="Calibri"/>
-                <a:cs typeface="Calibri"/>
-                <a:sym typeface="Calibri"/>
-              </a:rPr>
-              <a:t>  ✗ Más lento que Transformers, menor capacidad</a:t>
-            </a:r>
-            <a:endParaRPr/>
-          </a:p>
-          <a:p>
-            <a:pPr indent="0" lvl="0" marL="0" marR="0" rtl="0" algn="l">
-              <a:spcBef>
-                <a:spcPts val="800"/>
-              </a:spcBef>
-              <a:spcAft>
-                <a:spcPts val="0"/>
-              </a:spcAft>
-              <a:buNone/>
-            </a:pPr>
-            <a:r>
-              <a:t/>
-            </a:r>
-            <a:endParaRPr sz="1600">
-              <a:solidFill>
-                <a:schemeClr val="dk1"/>
-              </a:solidFill>
-              <a:latin typeface="Calibri"/>
-              <a:ea typeface="Calibri"/>
-              <a:cs typeface="Calibri"/>
-              <a:sym typeface="Calibri"/>
-            </a:endParaRPr>
-          </a:p>
-          <a:p>
-            <a:pPr indent="0" lvl="0" marL="0" marR="0" rtl="0" algn="l">
-              <a:spcBef>
-                <a:spcPts val="800"/>
-              </a:spcBef>
-              <a:spcAft>
-                <a:spcPts val="0"/>
-              </a:spcAft>
-              <a:buNone/>
-            </a:pPr>
-            <a:r>
-              <a:rPr lang="en-US" sz="1600">
-                <a:solidFill>
-                  <a:schemeClr val="dk1"/>
-                </a:solidFill>
-                <a:latin typeface="Calibri"/>
-                <a:ea typeface="Calibri"/>
-                <a:cs typeface="Calibri"/>
-                <a:sym typeface="Calibri"/>
-              </a:rPr>
-              <a:t>GPT (decoder-only):</a:t>
-            </a:r>
-            <a:endParaRPr/>
-          </a:p>
-          <a:p>
-            <a:pPr indent="0" lvl="0" marL="0" marR="0" rtl="0" algn="l">
-              <a:spcBef>
-                <a:spcPts val="800"/>
-              </a:spcBef>
-              <a:spcAft>
-                <a:spcPts val="0"/>
-              </a:spcAft>
-              <a:buNone/>
-            </a:pPr>
-            <a:r>
-              <a:rPr lang="en-US" sz="1600">
-                <a:solidFill>
-                  <a:schemeClr val="dk1"/>
-                </a:solidFill>
-                <a:latin typeface="Calibri"/>
-                <a:ea typeface="Calibri"/>
-                <a:cs typeface="Calibri"/>
-                <a:sym typeface="Calibri"/>
-              </a:rPr>
-              <a:t>  ✗ Unidireccional (solo contexto previo)</a:t>
-            </a:r>
-            <a:endParaRPr/>
-          </a:p>
-          <a:p>
-            <a:pPr indent="0" lvl="0" marL="0" marR="0" rtl="0" algn="l">
-              <a:spcBef>
-                <a:spcPts val="800"/>
-              </a:spcBef>
-              <a:spcAft>
-                <a:spcPts val="0"/>
-              </a:spcAft>
-              <a:buNone/>
-            </a:pPr>
-            <a:r>
-              <a:rPr lang="en-US" sz="1600">
-                <a:solidFill>
-                  <a:schemeClr val="dk1"/>
-                </a:solidFill>
-                <a:latin typeface="Calibri"/>
-                <a:ea typeface="Calibri"/>
-                <a:cs typeface="Calibri"/>
-                <a:sym typeface="Calibri"/>
-              </a:rPr>
-              <a:t>  ✓ Excelente para generación de texto</a:t>
-            </a:r>
-            <a:endParaRPr/>
-          </a:p>
-          <a:p>
-            <a:pPr indent="0" lvl="0" marL="0" marR="0" rtl="0" algn="l">
-              <a:spcBef>
-                <a:spcPts val="800"/>
-              </a:spcBef>
-              <a:spcAft>
-                <a:spcPts val="0"/>
-              </a:spcAft>
-              <a:buNone/>
-            </a:pPr>
-            <a:r>
-              <a:t/>
-            </a:r>
-            <a:endParaRPr sz="1600">
-              <a:solidFill>
-                <a:schemeClr val="dk1"/>
-              </a:solidFill>
-              <a:latin typeface="Calibri"/>
-              <a:ea typeface="Calibri"/>
-              <a:cs typeface="Calibri"/>
-              <a:sym typeface="Calibri"/>
-            </a:endParaRPr>
-          </a:p>
-          <a:p>
-            <a:pPr indent="0" lvl="0" marL="0" marR="0" rtl="0" algn="l">
-              <a:spcBef>
-                <a:spcPts val="800"/>
-              </a:spcBef>
-              <a:spcAft>
-                <a:spcPts val="0"/>
-              </a:spcAft>
-              <a:buNone/>
-            </a:pPr>
-            <a:r>
-              <a:rPr lang="en-US" sz="1600">
-                <a:solidFill>
-                  <a:schemeClr val="dk1"/>
-                </a:solidFill>
-                <a:latin typeface="Calibri"/>
-                <a:ea typeface="Calibri"/>
-                <a:cs typeface="Calibri"/>
-                <a:sym typeface="Calibri"/>
-              </a:rPr>
-              <a:t>BERT (encoder-only):</a:t>
-            </a:r>
-            <a:endParaRPr/>
-          </a:p>
-          <a:p>
-            <a:pPr indent="0" lvl="0" marL="0" marR="0" rtl="0" algn="l">
-              <a:spcBef>
-                <a:spcPts val="800"/>
-              </a:spcBef>
-              <a:spcAft>
-                <a:spcPts val="0"/>
-              </a:spcAft>
-              <a:buNone/>
-            </a:pPr>
-            <a:r>
-              <a:rPr lang="en-US" sz="1600">
-                <a:solidFill>
-                  <a:schemeClr val="dk1"/>
-                </a:solidFill>
-                <a:latin typeface="Calibri"/>
-                <a:ea typeface="Calibri"/>
-                <a:cs typeface="Calibri"/>
-                <a:sym typeface="Calibri"/>
-              </a:rPr>
-              <a:t>  ✓ Bidireccional: contexto completo (izquierda + derecha)</a:t>
-            </a:r>
-            <a:endParaRPr/>
-          </a:p>
-          <a:p>
-            <a:pPr indent="0" lvl="0" marL="0" marR="0" rtl="0" algn="l">
-              <a:spcBef>
-                <a:spcPts val="800"/>
-              </a:spcBef>
-              <a:spcAft>
-                <a:spcPts val="0"/>
-              </a:spcAft>
-              <a:buNone/>
-            </a:pPr>
-            <a:r>
-              <a:rPr lang="en-US" sz="1600">
-                <a:solidFill>
-                  <a:schemeClr val="dk1"/>
-                </a:solidFill>
-                <a:latin typeface="Calibri"/>
-                <a:ea typeface="Calibri"/>
-                <a:cs typeface="Calibri"/>
-                <a:sym typeface="Calibri"/>
-              </a:rPr>
-              <a:t>  ✓ State-of-the-art en clasificación (2018-2020)</a:t>
-            </a:r>
-            <a:endParaRPr/>
-          </a:p>
-          <a:p>
-            <a:pPr indent="0" lvl="0" marL="0" marR="0" rtl="0" algn="l">
-              <a:spcBef>
-                <a:spcPts val="800"/>
-              </a:spcBef>
-              <a:spcAft>
-                <a:spcPts val="0"/>
-              </a:spcAft>
-              <a:buNone/>
-            </a:pPr>
-            <a:r>
-              <a:rPr lang="en-US" sz="1600">
-                <a:solidFill>
-                  <a:schemeClr val="dk1"/>
-                </a:solidFill>
-                <a:latin typeface="Calibri"/>
-                <a:ea typeface="Calibri"/>
-                <a:cs typeface="Calibri"/>
-                <a:sym typeface="Calibri"/>
-              </a:rPr>
-              <a:t>  ✓ Modelo pre-entrenado disponible en Hugging Face</a:t>
-            </a:r>
-            <a:endParaRPr/>
-          </a:p>
-          <a:p>
-            <a:pPr indent="0" lvl="0" marL="0" marR="0" rtl="0" algn="l">
-              <a:spcBef>
-                <a:spcPts val="800"/>
-              </a:spcBef>
-              <a:spcAft>
-                <a:spcPts val="0"/>
-              </a:spcAft>
-              <a:buNone/>
-            </a:pPr>
-            <a:r>
-              <a:rPr lang="en-US" sz="1600">
-                <a:solidFill>
-                  <a:schemeClr val="dk1"/>
-                </a:solidFill>
-                <a:latin typeface="Calibri"/>
-                <a:ea typeface="Calibri"/>
-                <a:cs typeface="Calibri"/>
-                <a:sym typeface="Calibri"/>
-              </a:rPr>
-              <a:t>  ✓ Documentación extensa y comunidad activa</a:t>
-            </a:r>
-            <a:endParaRPr/>
-          </a:p>
-        </p:txBody>
-      </p:sp>
-    </p:spTree>
-  </p:cSld>
-  <p:clrMapOvr>
-    <a:masterClrMapping/>
-  </p:clrMapOvr>
-</p:sld>
-</file>
-
-<file path=ppt/slides/slide16.xml><?xml version="1.0" encoding="utf-8"?>
-<p:sld xmlns:a="http://schemas.openxmlformats.org/drawingml/2006/main" xmlns:r="http://schemas.openxmlformats.org/officeDocument/2006/relationships" xmlns:mc="http://schemas.openxmlformats.org/markup-compatibility/2006" xmlns:mv="urn:schemas-microsoft-com:mac:vml" xmlns:p="http://schemas.openxmlformats.org/presentationml/2006/main" xmlns:c="http://schemas.openxmlformats.org/drawingml/2006/chart" xmlns:dgm="http://schemas.openxmlformats.org/drawingml/2006/diagram" xmlns:o="urn:schemas-microsoft-com:office:office" xmlns:v="urn:schemas-microsoft-com:vml" xmlns:pvml="urn:schemas-microsoft-com:office:powerpoint" xmlns:com="http://schemas.openxmlformats.org/drawingml/2006/compatibility" xmlns:p14="http://schemas.microsoft.com/office/powerpoint/2010/main" xmlns:p15="http://schemas.microsoft.com/office/powerpoint/2012/main" xmlns:ahyp="http://schemas.microsoft.com/office/drawing/2018/hyperlinkcolor">
-  <p:cSld>
-    <p:spTree>
-      <p:nvGrpSpPr>
-        <p:cNvPr id="177" name="Shape 177"/>
-        <p:cNvGrpSpPr/>
-        <p:nvPr/>
-      </p:nvGrpSpPr>
-      <p:grpSpPr>
-        <a:xfrm>
-          <a:off x="0" y="0"/>
-          <a:ext cx="0" cy="0"/>
-          <a:chOff x="0" y="0"/>
-          <a:chExt cx="0" cy="0"/>
-        </a:xfrm>
-      </p:grpSpPr>
-      <p:sp>
-        <p:nvSpPr>
-          <p:cNvPr id="178" name="Google Shape;178;p15"/>
-          <p:cNvSpPr txBox="1"/>
-          <p:nvPr/>
-        </p:nvSpPr>
-        <p:spPr>
-          <a:xfrm>
-            <a:off x="457200" y="274320"/>
-            <a:ext cx="8229600" cy="731520"/>
-          </a:xfrm>
-          <a:prstGeom prst="rect">
-            <a:avLst/>
-          </a:prstGeom>
-          <a:noFill/>
-          <a:ln>
-            <a:noFill/>
-          </a:ln>
-        </p:spPr>
-        <p:txBody>
-          <a:bodyPr anchorCtr="0" anchor="t" bIns="45700" lIns="91425" spcFirstLastPara="1" rIns="91425" wrap="square" tIns="45700">
-            <a:spAutoFit/>
-          </a:bodyPr>
-          <a:lstStyle/>
-          <a:p>
-            <a:pPr indent="0" lvl="0" marL="0" marR="0" rtl="0" algn="l">
-              <a:spcBef>
-                <a:spcPts val="0"/>
-              </a:spcBef>
-              <a:spcAft>
-                <a:spcPts val="0"/>
-              </a:spcAft>
-              <a:buNone/>
-            </a:pPr>
-            <a:r>
-              <a:rPr b="1" lang="en-US" sz="2800">
-                <a:solidFill>
-                  <a:srgbClr val="003366"/>
-                </a:solidFill>
-                <a:latin typeface="Calibri"/>
-                <a:ea typeface="Calibri"/>
-                <a:cs typeface="Calibri"/>
-                <a:sym typeface="Calibri"/>
-              </a:rPr>
-              <a:t>Tokenización con BERT</a:t>
-            </a:r>
-            <a:endParaRPr/>
-          </a:p>
-        </p:txBody>
-      </p:sp>
-      <p:sp>
-        <p:nvSpPr>
-          <p:cNvPr id="179" name="Google Shape;179;p15"/>
+          <p:cNvPr id="181" name="Google Shape;181;p15"/>
           <p:cNvSpPr txBox="1"/>
           <p:nvPr/>
         </p:nvSpPr>
@@ -18410,7 +18375,7 @@
   <p:cSld>
     <p:spTree>
       <p:nvGrpSpPr>
-        <p:cNvPr id="183" name="Shape 183"/>
+        <p:cNvPr id="185" name="Shape 185"/>
         <p:cNvGrpSpPr/>
         <p:nvPr/>
       </p:nvGrpSpPr>
@@ -18424,7 +18389,7 @@
       </p:grpSpPr>
       <p:sp>
         <p:nvSpPr>
-          <p:cNvPr id="184" name="Google Shape;184;p16"/>
+          <p:cNvPr id="186" name="Google Shape;186;p16"/>
           <p:cNvSpPr txBox="1"/>
           <p:nvPr/>
         </p:nvSpPr>
@@ -18474,7 +18439,7 @@
       </p:sp>
       <p:sp>
         <p:nvSpPr>
-          <p:cNvPr id="185" name="Google Shape;185;p16"/>
+          <p:cNvPr id="187" name="Google Shape;187;p16"/>
           <p:cNvSpPr txBox="1"/>
           <p:nvPr/>
         </p:nvSpPr>
@@ -18567,7 +18532,7 @@
   <p:cSld>
     <p:spTree>
       <p:nvGrpSpPr>
-        <p:cNvPr id="189" name="Shape 189"/>
+        <p:cNvPr id="191" name="Shape 191"/>
         <p:cNvGrpSpPr/>
         <p:nvPr/>
       </p:nvGrpSpPr>
@@ -18581,7 +18546,7 @@
       </p:grpSpPr>
       <p:sp>
         <p:nvSpPr>
-          <p:cNvPr id="190" name="Google Shape;190;g3c8a0caada3_0_22"/>
+          <p:cNvPr id="192" name="Google Shape;192;g3c8a0caada3_0_22"/>
           <p:cNvSpPr txBox="1"/>
           <p:nvPr/>
         </p:nvSpPr>
@@ -18769,7 +18734,7 @@
       </p:sp>
       <p:sp>
         <p:nvSpPr>
-          <p:cNvPr id="191" name="Google Shape;191;g3c8a0caada3_0_22"/>
+          <p:cNvPr id="193" name="Google Shape;193;g3c8a0caada3_0_22"/>
           <p:cNvSpPr txBox="1"/>
           <p:nvPr/>
         </p:nvSpPr>
@@ -18830,7 +18795,7 @@
   <p:cSld>
     <p:spTree>
       <p:nvGrpSpPr>
-        <p:cNvPr id="195" name="Shape 195"/>
+        <p:cNvPr id="197" name="Shape 197"/>
         <p:cNvGrpSpPr/>
         <p:nvPr/>
       </p:nvGrpSpPr>
@@ -18844,7 +18809,7 @@
       </p:grpSpPr>
       <p:sp>
         <p:nvSpPr>
-          <p:cNvPr id="196" name="Google Shape;196;p17"/>
+          <p:cNvPr id="198" name="Google Shape;198;p17"/>
           <p:cNvSpPr txBox="1"/>
           <p:nvPr/>
         </p:nvSpPr>
@@ -18894,7 +18859,7 @@
       </p:sp>
       <p:sp>
         <p:nvSpPr>
-          <p:cNvPr id="197" name="Google Shape;197;p17"/>
+          <p:cNvPr id="199" name="Google Shape;199;p17"/>
           <p:cNvSpPr txBox="1"/>
           <p:nvPr/>
         </p:nvSpPr>
@@ -19351,7 +19316,7 @@
   <p:cSld>
     <p:spTree>
       <p:nvGrpSpPr>
-        <p:cNvPr id="201" name="Shape 201"/>
+        <p:cNvPr id="203" name="Shape 203"/>
         <p:cNvGrpSpPr/>
         <p:nvPr/>
       </p:nvGrpSpPr>
@@ -19365,7 +19330,7 @@
       </p:grpSpPr>
       <p:sp>
         <p:nvSpPr>
-          <p:cNvPr id="202" name="Google Shape;202;p18"/>
+          <p:cNvPr id="204" name="Google Shape;204;p18"/>
           <p:cNvSpPr txBox="1"/>
           <p:nvPr/>
         </p:nvSpPr>
@@ -19415,7 +19380,7 @@
       </p:sp>
       <p:sp>
         <p:nvSpPr>
-          <p:cNvPr id="203" name="Google Shape;203;p18"/>
+          <p:cNvPr id="205" name="Google Shape;205;p18"/>
           <p:cNvSpPr txBox="1"/>
           <p:nvPr/>
         </p:nvSpPr>
@@ -19815,7 +19780,7 @@
   <p:cSld>
     <p:spTree>
       <p:nvGrpSpPr>
-        <p:cNvPr id="207" name="Shape 207"/>
+        <p:cNvPr id="209" name="Shape 209"/>
         <p:cNvGrpSpPr/>
         <p:nvPr/>
       </p:nvGrpSpPr>
@@ -19829,7 +19794,7 @@
       </p:grpSpPr>
       <p:sp>
         <p:nvSpPr>
-          <p:cNvPr id="208" name="Google Shape;208;p19"/>
+          <p:cNvPr id="210" name="Google Shape;210;p19"/>
           <p:cNvSpPr txBox="1"/>
           <p:nvPr/>
         </p:nvSpPr>
@@ -19879,7 +19844,7 @@
       </p:sp>
       <p:sp>
         <p:nvSpPr>
-          <p:cNvPr id="209" name="Google Shape;209;p19"/>
+          <p:cNvPr id="211" name="Google Shape;211;p19"/>
           <p:cNvSpPr txBox="1"/>
           <p:nvPr/>
         </p:nvSpPr>
@@ -20266,7 +20231,7 @@
   <p:cSld>
     <p:spTree>
       <p:nvGrpSpPr>
-        <p:cNvPr id="213" name="Shape 213"/>
+        <p:cNvPr id="215" name="Shape 215"/>
         <p:cNvGrpSpPr/>
         <p:nvPr/>
       </p:nvGrpSpPr>
@@ -20280,7 +20245,7 @@
       </p:grpSpPr>
       <p:sp>
         <p:nvSpPr>
-          <p:cNvPr id="214" name="Google Shape;214;p20"/>
+          <p:cNvPr id="216" name="Google Shape;216;p20"/>
           <p:cNvSpPr txBox="1"/>
           <p:nvPr/>
         </p:nvSpPr>
@@ -20330,7 +20295,7 @@
       </p:sp>
       <p:sp>
         <p:nvSpPr>
-          <p:cNvPr id="215" name="Google Shape;215;p20"/>
+          <p:cNvPr id="217" name="Google Shape;217;p20"/>
           <p:cNvSpPr txBox="1"/>
           <p:nvPr/>
         </p:nvSpPr>
@@ -20391,7 +20356,7 @@
   <p:cSld>
     <p:spTree>
       <p:nvGrpSpPr>
-        <p:cNvPr id="219" name="Shape 219"/>
+        <p:cNvPr id="221" name="Shape 221"/>
         <p:cNvGrpSpPr/>
         <p:nvPr/>
       </p:nvGrpSpPr>
@@ -20405,7 +20370,7 @@
       </p:grpSpPr>
       <p:sp>
         <p:nvSpPr>
-          <p:cNvPr id="220" name="Google Shape;220;p21"/>
+          <p:cNvPr id="222" name="Google Shape;222;p21"/>
           <p:cNvSpPr txBox="1"/>
           <p:nvPr/>
         </p:nvSpPr>
@@ -20455,7 +20420,7 @@
       </p:sp>
       <p:sp>
         <p:nvSpPr>
-          <p:cNvPr id="221" name="Google Shape;221;p21"/>
+          <p:cNvPr id="223" name="Google Shape;223;p21"/>
           <p:cNvSpPr txBox="1"/>
           <p:nvPr/>
         </p:nvSpPr>
@@ -20707,7 +20672,7 @@
   <p:cSld>
     <p:spTree>
       <p:nvGrpSpPr>
-        <p:cNvPr id="225" name="Shape 225"/>
+        <p:cNvPr id="227" name="Shape 227"/>
         <p:cNvGrpSpPr/>
         <p:nvPr/>
       </p:nvGrpSpPr>
@@ -20721,7 +20686,7 @@
       </p:grpSpPr>
       <p:sp>
         <p:nvSpPr>
-          <p:cNvPr id="226" name="Google Shape;226;p22"/>
+          <p:cNvPr id="228" name="Google Shape;228;p22"/>
           <p:cNvSpPr txBox="1"/>
           <p:nvPr/>
         </p:nvSpPr>
@@ -20771,7 +20736,7 @@
       </p:sp>
       <p:sp>
         <p:nvSpPr>
-          <p:cNvPr id="227" name="Google Shape;227;p22"/>
+          <p:cNvPr id="229" name="Google Shape;229;p22"/>
           <p:cNvSpPr txBox="1"/>
           <p:nvPr/>
         </p:nvSpPr>
@@ -21155,7 +21120,7 @@
   <p:cSld>
     <p:spTree>
       <p:nvGrpSpPr>
-        <p:cNvPr id="231" name="Shape 231"/>
+        <p:cNvPr id="233" name="Shape 233"/>
         <p:cNvGrpSpPr/>
         <p:nvPr/>
       </p:nvGrpSpPr>
@@ -21169,7 +21134,7 @@
       </p:grpSpPr>
       <p:sp>
         <p:nvSpPr>
-          <p:cNvPr id="232" name="Google Shape;232;p23"/>
+          <p:cNvPr id="234" name="Google Shape;234;p23"/>
           <p:cNvSpPr txBox="1"/>
           <p:nvPr/>
         </p:nvSpPr>
@@ -21219,7 +21184,7 @@
       </p:sp>
       <p:sp>
         <p:nvSpPr>
-          <p:cNvPr id="233" name="Google Shape;233;p23"/>
+          <p:cNvPr id="235" name="Google Shape;235;p23"/>
           <p:cNvSpPr txBox="1"/>
           <p:nvPr/>
         </p:nvSpPr>
@@ -21651,7 +21616,7 @@
   <p:cSld>
     <p:spTree>
       <p:nvGrpSpPr>
-        <p:cNvPr id="237" name="Shape 237"/>
+        <p:cNvPr id="239" name="Shape 239"/>
         <p:cNvGrpSpPr/>
         <p:nvPr/>
       </p:nvGrpSpPr>
@@ -21665,7 +21630,7 @@
       </p:grpSpPr>
       <p:sp>
         <p:nvSpPr>
-          <p:cNvPr id="238" name="Google Shape;238;p24"/>
+          <p:cNvPr id="240" name="Google Shape;240;p24"/>
           <p:cNvSpPr txBox="1"/>
           <p:nvPr/>
         </p:nvSpPr>
@@ -21715,14 +21680,14 @@
       </p:sp>
       <p:sp>
         <p:nvSpPr>
-          <p:cNvPr id="239" name="Google Shape;239;p24"/>
+          <p:cNvPr id="241" name="Google Shape;241;p24"/>
           <p:cNvSpPr txBox="1"/>
           <p:nvPr/>
         </p:nvSpPr>
         <p:spPr>
           <a:xfrm>
             <a:off x="231175" y="704395"/>
-            <a:ext cx="8229600" cy="5571900"/>
+            <a:ext cx="8229600" cy="4874100"/>
           </a:xfrm>
           <a:prstGeom prst="rect">
             <a:avLst/>
@@ -22090,54 +22055,6 @@
                 <a:sym typeface="Calibri"/>
               </a:rPr>
               <a:t>• Pero 128 es suficiente para 95% de nuestras reseñas</a:t>
-            </a:r>
-            <a:endParaRPr/>
-          </a:p>
-          <a:p>
-            <a:pPr indent="0" lvl="0" marL="0" marR="0" rtl="0" algn="l">
-              <a:spcBef>
-                <a:spcPts val="800"/>
-              </a:spcBef>
-              <a:spcAft>
-                <a:spcPts val="0"/>
-              </a:spcAft>
-              <a:buNone/>
-            </a:pPr>
-            <a:r>
-              <a:rPr lang="en-US" sz="1600">
-                <a:solidFill>
-                  <a:schemeClr val="dk1"/>
-                </a:solidFill>
-                <a:latin typeface="Calibri"/>
-                <a:ea typeface="Calibri"/>
-                <a:cs typeface="Calibri"/>
-                <a:sym typeface="Calibri"/>
-              </a:rPr>
-              <a:t>• Menor memoria GPU → batch size más grande</a:t>
-            </a:r>
-            <a:endParaRPr/>
-          </a:p>
-          <a:p>
-            <a:pPr indent="0" lvl="0" marL="0" marR="0" rtl="0" algn="l">
-              <a:spcBef>
-                <a:spcPts val="800"/>
-              </a:spcBef>
-              <a:spcAft>
-                <a:spcPts val="0"/>
-              </a:spcAft>
-              <a:buNone/>
-            </a:pPr>
-            <a:r>
-              <a:rPr lang="en-US" sz="1600">
-                <a:solidFill>
-                  <a:schemeClr val="dk1"/>
-                </a:solidFill>
-                <a:latin typeface="Calibri"/>
-                <a:ea typeface="Calibri"/>
-                <a:cs typeface="Calibri"/>
-                <a:sym typeface="Calibri"/>
-              </a:rPr>
-              <a:t>• Training ~2x más rápido que con 512</a:t>
             </a:r>
             <a:endParaRPr/>
           </a:p>
@@ -22156,7 +22073,7 @@
   <p:cSld>
     <p:spTree>
       <p:nvGrpSpPr>
-        <p:cNvPr id="243" name="Shape 243"/>
+        <p:cNvPr id="245" name="Shape 245"/>
         <p:cNvGrpSpPr/>
         <p:nvPr/>
       </p:nvGrpSpPr>
@@ -22170,7 +22087,7 @@
       </p:grpSpPr>
       <p:sp>
         <p:nvSpPr>
-          <p:cNvPr id="244" name="Google Shape;244;p25"/>
+          <p:cNvPr id="246" name="Google Shape;246;p25"/>
           <p:cNvSpPr txBox="1"/>
           <p:nvPr/>
         </p:nvSpPr>
@@ -22220,7 +22137,7 @@
       </p:sp>
       <p:sp>
         <p:nvSpPr>
-          <p:cNvPr id="245" name="Google Shape;245;p25"/>
+          <p:cNvPr id="247" name="Google Shape;247;p25"/>
           <p:cNvSpPr txBox="1"/>
           <p:nvPr/>
         </p:nvSpPr>
@@ -22633,7 +22550,7 @@
   <p:cSld>
     <p:spTree>
       <p:nvGrpSpPr>
-        <p:cNvPr id="249" name="Shape 249"/>
+        <p:cNvPr id="251" name="Shape 251"/>
         <p:cNvGrpSpPr/>
         <p:nvPr/>
       </p:nvGrpSpPr>
@@ -22647,7 +22564,7 @@
       </p:grpSpPr>
       <p:sp>
         <p:nvSpPr>
-          <p:cNvPr id="250" name="Google Shape;250;p26"/>
+          <p:cNvPr id="252" name="Google Shape;252;p26"/>
           <p:cNvSpPr txBox="1"/>
           <p:nvPr/>
         </p:nvSpPr>
@@ -22697,7 +22614,7 @@
       </p:sp>
       <p:sp>
         <p:nvSpPr>
-          <p:cNvPr id="251" name="Google Shape;251;p26"/>
+          <p:cNvPr id="253" name="Google Shape;253;p26"/>
           <p:cNvSpPr txBox="1"/>
           <p:nvPr/>
         </p:nvSpPr>
@@ -23115,7 +23032,7 @@
   <p:cSld>
     <p:spTree>
       <p:nvGrpSpPr>
-        <p:cNvPr id="255" name="Shape 255"/>
+        <p:cNvPr id="257" name="Shape 257"/>
         <p:cNvGrpSpPr/>
         <p:nvPr/>
       </p:nvGrpSpPr>
@@ -23129,7 +23046,7 @@
       </p:grpSpPr>
       <p:sp>
         <p:nvSpPr>
-          <p:cNvPr id="256" name="Google Shape;256;p27"/>
+          <p:cNvPr id="258" name="Google Shape;258;p27"/>
           <p:cNvSpPr txBox="1"/>
           <p:nvPr/>
         </p:nvSpPr>
@@ -23179,7 +23096,7 @@
       </p:sp>
       <p:sp>
         <p:nvSpPr>
-          <p:cNvPr id="257" name="Google Shape;257;p27"/>
+          <p:cNvPr id="259" name="Google Shape;259;p27"/>
           <p:cNvSpPr txBox="1"/>
           <p:nvPr/>
         </p:nvSpPr>
@@ -23311,7 +23228,7 @@
         <p:spPr>
           <a:xfrm>
             <a:off x="457200" y="1188720"/>
-            <a:ext cx="8229600" cy="4073700"/>
+            <a:ext cx="8229600" cy="4320000"/>
           </a:xfrm>
           <a:prstGeom prst="rect">
             <a:avLst/>
@@ -23386,7 +23303,7 @@
                 <a:cs typeface="Calibri"/>
                 <a:sym typeface="Calibri"/>
               </a:rPr>
-              <a:t>utilizando. De esta forma, el clasificador deberá predecir si es positiva o negativa la reseña</a:t>
+              <a:t>utilizando fine-tuning de BERT. De esta forma, el clasificador deberá predecir si es positiva o negativa la reseña</a:t>
             </a:r>
             <a:endParaRPr/>
           </a:p>
@@ -23619,7 +23536,7 @@
   <p:cSld>
     <p:spTree>
       <p:nvGrpSpPr>
-        <p:cNvPr id="261" name="Shape 261"/>
+        <p:cNvPr id="263" name="Shape 263"/>
         <p:cNvGrpSpPr/>
         <p:nvPr/>
       </p:nvGrpSpPr>
@@ -23633,7 +23550,7 @@
       </p:grpSpPr>
       <p:sp>
         <p:nvSpPr>
-          <p:cNvPr id="262" name="Google Shape;262;p28"/>
+          <p:cNvPr id="264" name="Google Shape;264;p28"/>
           <p:cNvSpPr txBox="1"/>
           <p:nvPr/>
         </p:nvSpPr>
@@ -23683,7 +23600,7 @@
       </p:sp>
       <p:sp>
         <p:nvSpPr>
-          <p:cNvPr id="263" name="Google Shape;263;p28"/>
+          <p:cNvPr id="265" name="Google Shape;265;p28"/>
           <p:cNvSpPr txBox="1"/>
           <p:nvPr/>
         </p:nvSpPr>
@@ -24196,7 +24113,7 @@
   <p:cSld>
     <p:spTree>
       <p:nvGrpSpPr>
-        <p:cNvPr id="267" name="Shape 267"/>
+        <p:cNvPr id="269" name="Shape 269"/>
         <p:cNvGrpSpPr/>
         <p:nvPr/>
       </p:nvGrpSpPr>
@@ -24210,7 +24127,7 @@
       </p:grpSpPr>
       <p:sp>
         <p:nvSpPr>
-          <p:cNvPr id="268" name="Google Shape;268;p29"/>
+          <p:cNvPr id="270" name="Google Shape;270;p29"/>
           <p:cNvSpPr txBox="1"/>
           <p:nvPr/>
         </p:nvSpPr>
@@ -24260,7 +24177,7 @@
       </p:sp>
       <p:sp>
         <p:nvSpPr>
-          <p:cNvPr id="269" name="Google Shape;269;p29"/>
+          <p:cNvPr id="271" name="Google Shape;271;p29"/>
           <p:cNvSpPr txBox="1"/>
           <p:nvPr/>
         </p:nvSpPr>
@@ -24529,7 +24446,7 @@
       </p:sp>
       <p:pic>
         <p:nvPicPr>
-          <p:cNvPr id="270" name="Google Shape;270;p29"/>
+          <p:cNvPr id="272" name="Google Shape;272;p29"/>
           <p:cNvPicPr preferRelativeResize="0"/>
           <p:nvPr/>
         </p:nvPicPr>
@@ -24557,7 +24474,7 @@
       </p:pic>
       <p:pic>
         <p:nvPicPr>
-          <p:cNvPr id="271" name="Google Shape;271;p29"/>
+          <p:cNvPr id="273" name="Google Shape;273;p29"/>
           <p:cNvPicPr preferRelativeResize="0"/>
           <p:nvPr/>
         </p:nvPicPr>
@@ -24596,7 +24513,7 @@
   <p:cSld>
     <p:spTree>
       <p:nvGrpSpPr>
-        <p:cNvPr id="275" name="Shape 275"/>
+        <p:cNvPr id="277" name="Shape 277"/>
         <p:cNvGrpSpPr/>
         <p:nvPr/>
       </p:nvGrpSpPr>
@@ -24610,7 +24527,7 @@
       </p:grpSpPr>
       <p:sp>
         <p:nvSpPr>
-          <p:cNvPr id="276" name="Google Shape;276;p30"/>
+          <p:cNvPr id="278" name="Google Shape;278;p30"/>
           <p:cNvSpPr txBox="1"/>
           <p:nvPr/>
         </p:nvSpPr>
@@ -24660,7 +24577,7 @@
       </p:sp>
       <p:sp>
         <p:nvSpPr>
-          <p:cNvPr id="277" name="Google Shape;277;p30"/>
+          <p:cNvPr id="279" name="Google Shape;279;p30"/>
           <p:cNvSpPr txBox="1"/>
           <p:nvPr/>
         </p:nvSpPr>
@@ -24860,7 +24777,7 @@
   <p:cSld>
     <p:spTree>
       <p:nvGrpSpPr>
-        <p:cNvPr id="281" name="Shape 281"/>
+        <p:cNvPr id="283" name="Shape 283"/>
         <p:cNvGrpSpPr/>
         <p:nvPr/>
       </p:nvGrpSpPr>
@@ -24874,7 +24791,7 @@
       </p:grpSpPr>
       <p:sp>
         <p:nvSpPr>
-          <p:cNvPr id="282" name="Google Shape;282;p31"/>
+          <p:cNvPr id="284" name="Google Shape;284;p31"/>
           <p:cNvSpPr txBox="1"/>
           <p:nvPr/>
         </p:nvSpPr>
@@ -24924,7 +24841,7 @@
       </p:sp>
       <p:sp>
         <p:nvSpPr>
-          <p:cNvPr id="283" name="Google Shape;283;p31"/>
+          <p:cNvPr id="285" name="Google Shape;285;p31"/>
           <p:cNvSpPr txBox="1"/>
           <p:nvPr/>
         </p:nvSpPr>
@@ -25393,7 +25310,7 @@
   <p:cSld>
     <p:spTree>
       <p:nvGrpSpPr>
-        <p:cNvPr id="287" name="Shape 287"/>
+        <p:cNvPr id="289" name="Shape 289"/>
         <p:cNvGrpSpPr/>
         <p:nvPr/>
       </p:nvGrpSpPr>
@@ -25407,7 +25324,7 @@
       </p:grpSpPr>
       <p:sp>
         <p:nvSpPr>
-          <p:cNvPr id="288" name="Google Shape;288;p32"/>
+          <p:cNvPr id="290" name="Google Shape;290;p32"/>
           <p:cNvSpPr txBox="1"/>
           <p:nvPr/>
         </p:nvSpPr>
@@ -25457,7 +25374,7 @@
       </p:sp>
       <p:sp>
         <p:nvSpPr>
-          <p:cNvPr id="289" name="Google Shape;289;p32"/>
+          <p:cNvPr id="291" name="Google Shape;291;p32"/>
           <p:cNvSpPr txBox="1"/>
           <p:nvPr/>
         </p:nvSpPr>
@@ -25855,7 +25772,7 @@
   <p:cSld>
     <p:spTree>
       <p:nvGrpSpPr>
-        <p:cNvPr id="293" name="Shape 293"/>
+        <p:cNvPr id="295" name="Shape 295"/>
         <p:cNvGrpSpPr/>
         <p:nvPr/>
       </p:nvGrpSpPr>
@@ -25869,7 +25786,7 @@
       </p:grpSpPr>
       <p:pic>
         <p:nvPicPr>
-          <p:cNvPr id="294" name="Google Shape;294;g3c9478fcecd_0_0" title="confusion_matrix.png"/>
+          <p:cNvPr id="296" name="Google Shape;296;g3c9478fcecd_0_0" title="confusion_matrix.png"/>
           <p:cNvPicPr preferRelativeResize="0"/>
           <p:nvPr/>
         </p:nvPicPr>
@@ -25897,7 +25814,7 @@
       </p:pic>
       <p:pic>
         <p:nvPicPr>
-          <p:cNvPr id="295" name="Google Shape;295;g3c9478fcecd_0_0" title="training_loss.png"/>
+          <p:cNvPr id="297" name="Google Shape;297;g3c9478fcecd_0_0" title="training_loss.png"/>
           <p:cNvPicPr preferRelativeResize="0"/>
           <p:nvPr/>
         </p:nvPicPr>
@@ -25936,7 +25853,7 @@
   <p:cSld>
     <p:spTree>
       <p:nvGrpSpPr>
-        <p:cNvPr id="299" name="Shape 299"/>
+        <p:cNvPr id="301" name="Shape 301"/>
         <p:cNvGrpSpPr/>
         <p:nvPr/>
       </p:nvGrpSpPr>
@@ -25950,7 +25867,7 @@
       </p:grpSpPr>
       <p:sp>
         <p:nvSpPr>
-          <p:cNvPr id="300" name="Google Shape;300;p33"/>
+          <p:cNvPr id="302" name="Google Shape;302;p33"/>
           <p:cNvSpPr txBox="1"/>
           <p:nvPr/>
         </p:nvSpPr>
@@ -26000,7 +25917,7 @@
       </p:sp>
       <p:sp>
         <p:nvSpPr>
-          <p:cNvPr id="301" name="Google Shape;301;p33"/>
+          <p:cNvPr id="303" name="Google Shape;303;p33"/>
           <p:cNvSpPr txBox="1"/>
           <p:nvPr/>
         </p:nvSpPr>
@@ -26413,7 +26330,7 @@
   <p:cSld>
     <p:spTree>
       <p:nvGrpSpPr>
-        <p:cNvPr id="305" name="Shape 305"/>
+        <p:cNvPr id="307" name="Shape 307"/>
         <p:cNvGrpSpPr/>
         <p:nvPr/>
       </p:nvGrpSpPr>
@@ -26427,7 +26344,7 @@
       </p:grpSpPr>
       <p:sp>
         <p:nvSpPr>
-          <p:cNvPr id="306" name="Google Shape;306;p34"/>
+          <p:cNvPr id="308" name="Google Shape;308;p34"/>
           <p:cNvSpPr txBox="1"/>
           <p:nvPr/>
         </p:nvSpPr>
@@ -26477,7 +26394,7 @@
       </p:sp>
       <p:sp>
         <p:nvSpPr>
-          <p:cNvPr id="307" name="Google Shape;307;p34"/>
+          <p:cNvPr id="309" name="Google Shape;309;p34"/>
           <p:cNvSpPr txBox="1"/>
           <p:nvPr/>
         </p:nvSpPr>
@@ -26885,7 +26802,7 @@
   <p:cSld>
     <p:spTree>
       <p:nvGrpSpPr>
-        <p:cNvPr id="311" name="Shape 311"/>
+        <p:cNvPr id="313" name="Shape 313"/>
         <p:cNvGrpSpPr/>
         <p:nvPr/>
       </p:nvGrpSpPr>
@@ -26899,7 +26816,7 @@
       </p:grpSpPr>
       <p:sp>
         <p:nvSpPr>
-          <p:cNvPr id="312" name="Google Shape;312;p35"/>
+          <p:cNvPr id="314" name="Google Shape;314;p35"/>
           <p:cNvSpPr txBox="1"/>
           <p:nvPr/>
         </p:nvSpPr>
@@ -26949,7 +26866,7 @@
       </p:sp>
       <p:sp>
         <p:nvSpPr>
-          <p:cNvPr id="313" name="Google Shape;313;p35"/>
+          <p:cNvPr id="315" name="Google Shape;315;p35"/>
           <p:cNvSpPr txBox="1"/>
           <p:nvPr/>
         </p:nvSpPr>
@@ -27010,7 +26927,7 @@
   <p:cSld>
     <p:spTree>
       <p:nvGrpSpPr>
-        <p:cNvPr id="317" name="Shape 317"/>
+        <p:cNvPr id="319" name="Shape 319"/>
         <p:cNvGrpSpPr/>
         <p:nvPr/>
       </p:nvGrpSpPr>
@@ -27024,7 +26941,7 @@
       </p:grpSpPr>
       <p:sp>
         <p:nvSpPr>
-          <p:cNvPr id="318" name="Google Shape;318;p36"/>
+          <p:cNvPr id="320" name="Google Shape;320;p36"/>
           <p:cNvSpPr txBox="1"/>
           <p:nvPr/>
         </p:nvSpPr>
@@ -27074,7 +26991,7 @@
       </p:sp>
       <p:sp>
         <p:nvSpPr>
-          <p:cNvPr id="319" name="Google Shape;319;p36"/>
+          <p:cNvPr id="321" name="Google Shape;321;p36"/>
           <p:cNvSpPr txBox="1"/>
           <p:nvPr/>
         </p:nvSpPr>
@@ -27578,7 +27495,7 @@
   <p:cSld>
     <p:spTree>
       <p:nvGrpSpPr>
-        <p:cNvPr id="323" name="Shape 323"/>
+        <p:cNvPr id="325" name="Shape 325"/>
         <p:cNvGrpSpPr/>
         <p:nvPr/>
       </p:nvGrpSpPr>
@@ -27592,7 +27509,7 @@
       </p:grpSpPr>
       <p:sp>
         <p:nvSpPr>
-          <p:cNvPr id="324" name="Google Shape;324;p37"/>
+          <p:cNvPr id="326" name="Google Shape;326;p37"/>
           <p:cNvSpPr txBox="1"/>
           <p:nvPr/>
         </p:nvSpPr>
@@ -27642,7 +27559,7 @@
       </p:sp>
       <p:sp>
         <p:nvSpPr>
-          <p:cNvPr id="325" name="Google Shape;325;p37"/>
+          <p:cNvPr id="327" name="Google Shape;327;p37"/>
           <p:cNvSpPr txBox="1"/>
           <p:nvPr/>
         </p:nvSpPr>
@@ -28139,7 +28056,7 @@
   <p:cSld>
     <p:spTree>
       <p:nvGrpSpPr>
-        <p:cNvPr id="329" name="Shape 329"/>
+        <p:cNvPr id="331" name="Shape 331"/>
         <p:cNvGrpSpPr/>
         <p:nvPr/>
       </p:nvGrpSpPr>
@@ -28153,7 +28070,7 @@
       </p:grpSpPr>
       <p:sp>
         <p:nvSpPr>
-          <p:cNvPr id="330" name="Google Shape;330;g39421e1b5d2_0_0"/>
+          <p:cNvPr id="332" name="Google Shape;332;g39421e1b5d2_0_0"/>
           <p:cNvSpPr txBox="1"/>
           <p:nvPr/>
         </p:nvSpPr>
@@ -28203,7 +28120,7 @@
       </p:sp>
       <p:sp>
         <p:nvSpPr>
-          <p:cNvPr id="331" name="Google Shape;331;g39421e1b5d2_0_0"/>
+          <p:cNvPr id="333" name="Google Shape;333;g39421e1b5d2_0_0"/>
           <p:cNvSpPr txBox="1"/>
           <p:nvPr/>
         </p:nvSpPr>
@@ -28700,7 +28617,7 @@
   <p:cSld>
     <p:spTree>
       <p:nvGrpSpPr>
-        <p:cNvPr id="335" name="Shape 335"/>
+        <p:cNvPr id="337" name="Shape 337"/>
         <p:cNvGrpSpPr/>
         <p:nvPr/>
       </p:nvGrpSpPr>
@@ -28714,7 +28631,7 @@
       </p:grpSpPr>
       <p:sp>
         <p:nvSpPr>
-          <p:cNvPr id="336" name="Google Shape;336;p38"/>
+          <p:cNvPr id="338" name="Google Shape;338;p38"/>
           <p:cNvSpPr txBox="1"/>
           <p:nvPr/>
         </p:nvSpPr>
@@ -28764,7 +28681,7 @@
       </p:sp>
       <p:sp>
         <p:nvSpPr>
-          <p:cNvPr id="337" name="Google Shape;337;p38"/>
+          <p:cNvPr id="339" name="Google Shape;339;p38"/>
           <p:cNvSpPr txBox="1"/>
           <p:nvPr/>
         </p:nvSpPr>
@@ -29177,7 +29094,7 @@
   <p:cSld>
     <p:spTree>
       <p:nvGrpSpPr>
-        <p:cNvPr id="341" name="Shape 341"/>
+        <p:cNvPr id="343" name="Shape 343"/>
         <p:cNvGrpSpPr/>
         <p:nvPr/>
       </p:nvGrpSpPr>
@@ -29191,7 +29108,7 @@
       </p:grpSpPr>
       <p:sp>
         <p:nvSpPr>
-          <p:cNvPr id="342" name="Google Shape;342;p43"/>
+          <p:cNvPr id="344" name="Google Shape;344;p43"/>
           <p:cNvSpPr txBox="1"/>
           <p:nvPr/>
         </p:nvSpPr>
@@ -29256,7 +29173,7 @@
   <p:cSld>
     <p:spTree>
       <p:nvGrpSpPr>
-        <p:cNvPr id="346" name="Shape 346"/>
+        <p:cNvPr id="348" name="Shape 348"/>
         <p:cNvGrpSpPr/>
         <p:nvPr/>
       </p:nvGrpSpPr>
@@ -29270,7 +29187,7 @@
       </p:grpSpPr>
       <p:sp>
         <p:nvSpPr>
-          <p:cNvPr id="347" name="Google Shape;347;g3c9478fcecd_0_8"/>
+          <p:cNvPr id="349" name="Google Shape;349;g3c9478fcecd_0_8"/>
           <p:cNvSpPr txBox="1"/>
           <p:nvPr/>
         </p:nvSpPr>
@@ -29362,7 +29279,7 @@
   <p:cSld>
     <p:spTree>
       <p:nvGrpSpPr>
-        <p:cNvPr id="351" name="Shape 351"/>
+        <p:cNvPr id="353" name="Shape 353"/>
         <p:cNvGrpSpPr/>
         <p:nvPr/>
       </p:nvGrpSpPr>
@@ -29376,7 +29293,7 @@
       </p:grpSpPr>
       <p:sp>
         <p:nvSpPr>
-          <p:cNvPr id="352" name="Google Shape;352;p51"/>
+          <p:cNvPr id="354" name="Google Shape;354;p51"/>
           <p:cNvSpPr txBox="1"/>
           <p:nvPr/>
         </p:nvSpPr>
@@ -29437,7 +29354,7 @@
   <p:cSld>
     <p:spTree>
       <p:nvGrpSpPr>
-        <p:cNvPr id="356" name="Shape 356"/>
+        <p:cNvPr id="358" name="Shape 358"/>
         <p:cNvGrpSpPr/>
         <p:nvPr/>
       </p:nvGrpSpPr>
@@ -29451,7 +29368,7 @@
       </p:grpSpPr>
       <p:sp>
         <p:nvSpPr>
-          <p:cNvPr id="357" name="Google Shape;357;p57"/>
+          <p:cNvPr id="359" name="Google Shape;359;p57"/>
           <p:cNvSpPr txBox="1"/>
           <p:nvPr/>
         </p:nvSpPr>
@@ -29501,7 +29418,7 @@
       </p:sp>
       <p:sp>
         <p:nvSpPr>
-          <p:cNvPr id="358" name="Google Shape;358;p57"/>
+          <p:cNvPr id="360" name="Google Shape;360;p57"/>
           <p:cNvSpPr txBox="1"/>
           <p:nvPr/>
         </p:nvSpPr>
@@ -30247,6 +30164,83 @@
           </a:p>
         </p:txBody>
       </p:sp>
+      <p:pic>
+        <p:nvPicPr>
+          <p:cNvPr id="112" name="Google Shape;112;p5"/>
+          <p:cNvPicPr preferRelativeResize="0"/>
+          <p:nvPr/>
+        </p:nvPicPr>
+        <p:blipFill>
+          <a:blip r:embed="rId4">
+            <a:alphaModFix/>
+          </a:blip>
+          <a:stretch>
+            <a:fillRect/>
+          </a:stretch>
+        </p:blipFill>
+        <p:spPr>
+          <a:xfrm>
+            <a:off x="841518" y="5545718"/>
+            <a:ext cx="3858986" cy="1157275"/>
+          </a:xfrm>
+          <a:prstGeom prst="rect">
+            <a:avLst/>
+          </a:prstGeom>
+          <a:noFill/>
+          <a:ln>
+            <a:noFill/>
+          </a:ln>
+        </p:spPr>
+      </p:pic>
+      <p:sp>
+        <p:nvSpPr>
+          <p:cNvPr id="113" name="Google Shape;113;p5"/>
+          <p:cNvSpPr txBox="1"/>
+          <p:nvPr/>
+        </p:nvSpPr>
+        <p:spPr>
+          <a:xfrm>
+            <a:off x="5814025" y="6584625"/>
+            <a:ext cx="51600" cy="84000"/>
+          </a:xfrm>
+          <a:prstGeom prst="rect">
+            <a:avLst/>
+          </a:prstGeom>
+          <a:noFill/>
+          <a:ln>
+            <a:noFill/>
+          </a:ln>
+        </p:spPr>
+        <p:txBody>
+          <a:bodyPr anchorCtr="0" anchor="t" bIns="91425" lIns="91425" spcFirstLastPara="1" rIns="91425" wrap="square" tIns="91425">
+            <a:noAutofit/>
+          </a:bodyPr>
+          <a:lstStyle/>
+          <a:p>
+            <a:pPr indent="0" lvl="0" marL="0" rtl="0" algn="l">
+              <a:spcBef>
+                <a:spcPts val="0"/>
+              </a:spcBef>
+              <a:spcAft>
+                <a:spcPts val="0"/>
+              </a:spcAft>
+              <a:buNone/>
+            </a:pPr>
+            <a:r>
+              <a:t/>
+            </a:r>
+            <a:endParaRPr sz="3200">
+              <a:solidFill>
+                <a:schemeClr val="dk1"/>
+              </a:solidFill>
+              <a:latin typeface="Calibri"/>
+              <a:ea typeface="Calibri"/>
+              <a:cs typeface="Calibri"/>
+              <a:sym typeface="Calibri"/>
+            </a:endParaRPr>
+          </a:p>
+        </p:txBody>
+      </p:sp>
     </p:spTree>
   </p:cSld>
   <p:clrMapOvr>
@@ -30260,7 +30254,7 @@
   <p:cSld>
     <p:spTree>
       <p:nvGrpSpPr>
-        <p:cNvPr id="115" name="Shape 115"/>
+        <p:cNvPr id="117" name="Shape 117"/>
         <p:cNvGrpSpPr/>
         <p:nvPr/>
       </p:nvGrpSpPr>
@@ -30274,7 +30268,7 @@
       </p:grpSpPr>
       <p:sp>
         <p:nvSpPr>
-          <p:cNvPr id="116" name="Google Shape;116;p6"/>
+          <p:cNvPr id="118" name="Google Shape;118;p6"/>
           <p:cNvSpPr txBox="1"/>
           <p:nvPr/>
         </p:nvSpPr>
@@ -30324,7 +30318,7 @@
       </p:sp>
       <p:pic>
         <p:nvPicPr>
-          <p:cNvPr id="117" name="Google Shape;117;p6"/>
+          <p:cNvPr id="119" name="Google Shape;119;p6"/>
           <p:cNvPicPr preferRelativeResize="0"/>
           <p:nvPr/>
         </p:nvPicPr>
@@ -30352,7 +30346,7 @@
       </p:pic>
       <p:sp>
         <p:nvSpPr>
-          <p:cNvPr id="118" name="Google Shape;118;p6"/>
+          <p:cNvPr id="120" name="Google Shape;120;p6"/>
           <p:cNvSpPr txBox="1"/>
           <p:nvPr/>
         </p:nvSpPr>
@@ -30818,7 +30812,7 @@
   <p:cSld>
     <p:spTree>
       <p:nvGrpSpPr>
-        <p:cNvPr id="122" name="Shape 122"/>
+        <p:cNvPr id="124" name="Shape 124"/>
         <p:cNvGrpSpPr/>
         <p:nvPr/>
       </p:nvGrpSpPr>
@@ -30832,7 +30826,7 @@
       </p:grpSpPr>
       <p:sp>
         <p:nvSpPr>
-          <p:cNvPr id="123" name="Google Shape;123;p7"/>
+          <p:cNvPr id="125" name="Google Shape;125;p7"/>
           <p:cNvSpPr txBox="1"/>
           <p:nvPr/>
         </p:nvSpPr>
@@ -30882,7 +30876,7 @@
       </p:sp>
       <p:sp>
         <p:nvSpPr>
-          <p:cNvPr id="124" name="Google Shape;124;p7"/>
+          <p:cNvPr id="126" name="Google Shape;126;p7"/>
           <p:cNvSpPr txBox="1"/>
           <p:nvPr/>
         </p:nvSpPr>
@@ -31298,7 +31292,7 @@
   <p:cSld>
     <p:spTree>
       <p:nvGrpSpPr>
-        <p:cNvPr id="128" name="Shape 128"/>
+        <p:cNvPr id="130" name="Shape 130"/>
         <p:cNvGrpSpPr/>
         <p:nvPr/>
       </p:nvGrpSpPr>
@@ -31312,7 +31306,7 @@
       </p:grpSpPr>
       <p:sp>
         <p:nvSpPr>
-          <p:cNvPr id="129" name="Google Shape;129;p8"/>
+          <p:cNvPr id="131" name="Google Shape;131;p8"/>
           <p:cNvSpPr txBox="1"/>
           <p:nvPr/>
         </p:nvSpPr>
@@ -31362,7 +31356,7 @@
       </p:sp>
       <p:sp>
         <p:nvSpPr>
-          <p:cNvPr id="130" name="Google Shape;130;p8"/>
+          <p:cNvPr id="132" name="Google Shape;132;p8"/>
           <p:cNvSpPr txBox="1"/>
           <p:nvPr/>
         </p:nvSpPr>
@@ -31778,7 +31772,7 @@
   <p:cSld>
     <p:spTree>
       <p:nvGrpSpPr>
-        <p:cNvPr id="134" name="Shape 134"/>
+        <p:cNvPr id="136" name="Shape 136"/>
         <p:cNvGrpSpPr/>
         <p:nvPr/>
       </p:nvGrpSpPr>
@@ -31792,7 +31786,7 @@
       </p:grpSpPr>
       <p:sp>
         <p:nvSpPr>
-          <p:cNvPr id="135" name="Google Shape;135;p9"/>
+          <p:cNvPr id="137" name="Google Shape;137;p9"/>
           <p:cNvSpPr txBox="1"/>
           <p:nvPr/>
         </p:nvSpPr>
@@ -31842,7 +31836,7 @@
       </p:sp>
       <p:sp>
         <p:nvSpPr>
-          <p:cNvPr id="136" name="Google Shape;136;p9"/>
+          <p:cNvPr id="138" name="Google Shape;138;p9"/>
           <p:cNvSpPr txBox="1"/>
           <p:nvPr/>
         </p:nvSpPr>

</xml_diff>